<commit_message>
Expand 8/24 deck with purpose, sim-vs-real, method review, and 4-week plan
작업 후 논의 내용을 반영해 4장 추가 (14→17장) 및 기존 슬라이드 갱신.

추가:
- 왜 카메라를 설치했나: 정책 입력이 이미지 2장이라 sim 구동에 렌더가 필수.
  결론의 비대칭(성공해도 실물 보장 아님/실패해도 원인 구분 불가) 명시
- 가상 vs 실물 카메라: 변신이 아니라 같은 자리에 번갈아 꽂히는 두 장치.
  마운트 설계 시 FOV는 부품이 결정하므로 오늘 값 그대로 복사 불가
- 방법 재평가: 실물 실측 · solvePnP · hand-eye · 정책 액션 오차 지표 ·
  포즈 랜덤화. PnP 를 '타깃 없음'으로 기각한 것은 오판이었음을 정정
  (큐브 파지 위치 159쌍이 곧 3D↔2D 대응)
- 범위 조정 + 4주 계획: v7 이어학습 경로 확정으로 STEP 5-3/5-4 우선순위
  하향, 실물 도착(9/20) 준비 선행. LEHR 확정이 최우선 병목

대화록 20260824.md 도 이후 대화 포함해 재생성 (4,528줄).

Co-Authored-By: Claude Fable 5 <noreply@anthropic.com>
</commit_message>
<xml_diff>
--- a/대화록 및 PPT/M1013_카메라정합_20260824.pptx
+++ b/대화록 및 PPT/M1013_카메라정합_20260824.pptx
@@ -19,6 +19,9 @@
     <p:sldId id="267" r:id="rId18"/>
     <p:sldId id="268" r:id="rId19"/>
     <p:sldId id="269" r:id="rId20"/>
+    <p:sldId id="270" r:id="rId21"/>
+    <p:sldId id="271" r:id="rId22"/>
+    <p:sldId id="272" r:id="rId23"/>
   </p:sldIdLst>
   <p:sldSz cx="12192119" cy="6858000" type="screen4x3"/>
   <p:notesSz cx="6858000" cy="9144000"/>
@@ -3221,7 +3224,7 @@
                 </a:solidFill>
                 <a:latin typeface="맑은 고딕"/>
               </a:rPr>
-              <a:t>다음 단계:  STEP 5-3 closed-loop — 이 카메라의 렌더를 관측으로 정책 실시간 제어</a:t>
+              <a:t>범위 조정:  v7 실기 이어학습 경로 확정 → closed-loop 우선순위 하향, 실물 도착(9/20) 준비 선행</a:t>
             </a:r>
           </a:p>
         </p:txBody>
@@ -5019,7 +5022,7 @@
                 </a:solidFill>
                 <a:latin typeface="맑은 고딕"/>
               </a:rPr>
-              <a:t>08 다음  </a:t>
+              <a:t>08 목적  </a:t>
             </a:r>
             <a:r>
               <a:rPr sz="2100" b="1">
@@ -5028,583 +5031,21 @@
                 </a:solidFill>
                 <a:latin typeface="맑은 고딕"/>
               </a:rPr>
-              <a:t>다음 시작점 — STEP 5-3 closed-loop 첫 가동</a:t>
-            </a:r>
-          </a:p>
-        </p:txBody>
-      </p:sp>
-      <p:sp>
-        <p:nvSpPr>
-          <p:cNvPr id="3" name="Rounded Rectangle 2"/>
-          <p:cNvSpPr/>
-          <p:nvPr/>
-        </p:nvSpPr>
-        <p:spPr>
-          <a:xfrm>
-            <a:off x="324000" y="936000"/>
-            <a:ext cx="2106000" cy="900000"/>
-          </a:xfrm>
-          <a:prstGeom prst="roundRect">
-            <a:avLst/>
-          </a:prstGeom>
-          <a:solidFill>
-            <a:srgbClr val="2F3D9E"/>
-          </a:solidFill>
-          <a:ln w="9525">
-            <a:solidFill>
-              <a:srgbClr val="C6CCD8"/>
-            </a:solidFill>
-          </a:ln>
-        </p:spPr>
-        <p:style>
-          <a:lnRef idx="1">
-            <a:schemeClr val="accent1"/>
-          </a:lnRef>
-          <a:fillRef idx="3">
-            <a:schemeClr val="accent1"/>
-          </a:fillRef>
-          <a:effectRef idx="2">
-            <a:schemeClr val="accent1"/>
-          </a:effectRef>
-          <a:fontRef idx="minor">
-            <a:schemeClr val="lt1"/>
-          </a:fontRef>
-        </p:style>
-        <p:txBody>
-          <a:bodyPr rtlCol="0" anchor="ctr" wrap="square" lIns="36000" rIns="36000" tIns="21600" bIns="21600"/>
-          <a:lstStyle/>
-          <a:p>
-            <a:pPr algn="ctr"/>
-            <a:r>
-              <a:rPr sz="1200" b="1">
-                <a:solidFill>
-                  <a:srgbClr val="FFFFFF"/>
-                </a:solidFill>
-                <a:latin typeface="맑은 고딕"/>
-              </a:rPr>
-              <a:t>① 렌더 루프 조립</a:t>
-            </a:r>
-          </a:p>
-          <a:p>
-            <a:pPr algn="ctr"/>
-            <a:r>
-              <a:rPr sz="1000" b="0">
-                <a:solidFill>
-                  <a:srgbClr val="FFFFFF"/>
-                </a:solidFill>
-                <a:latin typeface="맑은 고딕"/>
-              </a:rPr>
-              <a:t>replay_isaac 씬</a:t>
-            </a:r>
-          </a:p>
-          <a:p>
-            <a:pPr algn="ctr"/>
-            <a:r>
-              <a:rPr sz="1000" b="0">
-                <a:solidFill>
-                  <a:srgbClr val="FFFFFF"/>
-                </a:solidFill>
-                <a:latin typeface="맑은 고딕"/>
-              </a:rPr>
-              <a:t>+ JSON 카메라 2대</a:t>
-            </a:r>
-          </a:p>
-        </p:txBody>
-      </p:sp>
-      <p:sp>
-        <p:nvSpPr>
-          <p:cNvPr id="4" name="Right Arrow 3"/>
-          <p:cNvSpPr/>
-          <p:nvPr/>
-        </p:nvSpPr>
-        <p:spPr>
-          <a:xfrm>
-            <a:off x="2430000" y="1296000"/>
-            <a:ext cx="251999" cy="180000"/>
-          </a:xfrm>
-          <a:prstGeom prst="rightArrow">
-            <a:avLst/>
-          </a:prstGeom>
-          <a:solidFill>
-            <a:srgbClr val="626B78"/>
-          </a:solidFill>
-          <a:ln>
-            <a:noFill/>
-          </a:ln>
-        </p:spPr>
-        <p:style>
-          <a:lnRef idx="1">
-            <a:schemeClr val="accent1"/>
-          </a:lnRef>
-          <a:fillRef idx="3">
-            <a:schemeClr val="accent1"/>
-          </a:fillRef>
-          <a:effectRef idx="2">
-            <a:schemeClr val="accent1"/>
-          </a:effectRef>
-          <a:fontRef idx="minor">
-            <a:schemeClr val="lt1"/>
-          </a:fontRef>
-        </p:style>
-        <p:txBody>
-          <a:bodyPr rtlCol="0" anchor="ctr"/>
-          <a:lstStyle/>
-          <a:p>
-            <a:pPr algn="ctr"/>
-          </a:p>
-        </p:txBody>
-      </p:sp>
-      <p:sp>
-        <p:nvSpPr>
-          <p:cNvPr id="5" name="Rounded Rectangle 4"/>
-          <p:cNvSpPr/>
-          <p:nvPr/>
-        </p:nvSpPr>
-        <p:spPr>
-          <a:xfrm>
-            <a:off x="2681999" y="936000"/>
-            <a:ext cx="2106000" cy="900000"/>
-          </a:xfrm>
-          <a:prstGeom prst="roundRect">
-            <a:avLst/>
-          </a:prstGeom>
-          <a:solidFill>
-            <a:srgbClr val="2F3D9E"/>
-          </a:solidFill>
-          <a:ln w="9525">
-            <a:solidFill>
-              <a:srgbClr val="C6CCD8"/>
-            </a:solidFill>
-          </a:ln>
-        </p:spPr>
-        <p:style>
-          <a:lnRef idx="1">
-            <a:schemeClr val="accent1"/>
-          </a:lnRef>
-          <a:fillRef idx="3">
-            <a:schemeClr val="accent1"/>
-          </a:fillRef>
-          <a:effectRef idx="2">
-            <a:schemeClr val="accent1"/>
-          </a:effectRef>
-          <a:fontRef idx="minor">
-            <a:schemeClr val="lt1"/>
-          </a:fontRef>
-        </p:style>
-        <p:txBody>
-          <a:bodyPr rtlCol="0" anchor="ctr" wrap="square" lIns="36000" rIns="36000" tIns="21600" bIns="21600"/>
-          <a:lstStyle/>
-          <a:p>
-            <a:pPr algn="ctr"/>
-            <a:r>
-              <a:rPr sz="1200" b="1">
-                <a:solidFill>
-                  <a:srgbClr val="FFFFFF"/>
-                </a:solidFill>
-                <a:latin typeface="맑은 고딕"/>
-              </a:rPr>
-              <a:t>② 관측 파이프</a:t>
-            </a:r>
-          </a:p>
-          <a:p>
-            <a:pPr algn="ctr"/>
-            <a:r>
-              <a:rPr sz="1000" b="0">
-                <a:solidFill>
-                  <a:srgbClr val="FFFFFF"/>
-                </a:solidFill>
-                <a:latin typeface="맑은 고딕"/>
-              </a:rPr>
-              <a:t>매 스텝 640×480 2뷰</a:t>
-            </a:r>
-          </a:p>
-          <a:p>
-            <a:pPr algn="ctr"/>
-            <a:r>
-              <a:rPr sz="1000" b="0">
-                <a:solidFill>
-                  <a:srgbClr val="FFFFFF"/>
-                </a:solidFill>
-                <a:latin typeface="맑은 고딕"/>
-              </a:rPr>
-              <a:t>+ state(관절 실측)</a:t>
-            </a:r>
-          </a:p>
-        </p:txBody>
-      </p:sp>
-      <p:sp>
-        <p:nvSpPr>
-          <p:cNvPr id="6" name="Right Arrow 5"/>
-          <p:cNvSpPr/>
-          <p:nvPr/>
-        </p:nvSpPr>
-        <p:spPr>
-          <a:xfrm>
-            <a:off x="4787999" y="1296000"/>
-            <a:ext cx="251999" cy="180000"/>
-          </a:xfrm>
-          <a:prstGeom prst="rightArrow">
-            <a:avLst/>
-          </a:prstGeom>
-          <a:solidFill>
-            <a:srgbClr val="626B78"/>
-          </a:solidFill>
-          <a:ln>
-            <a:noFill/>
-          </a:ln>
-        </p:spPr>
-        <p:style>
-          <a:lnRef idx="1">
-            <a:schemeClr val="accent1"/>
-          </a:lnRef>
-          <a:fillRef idx="3">
-            <a:schemeClr val="accent1"/>
-          </a:fillRef>
-          <a:effectRef idx="2">
-            <a:schemeClr val="accent1"/>
-          </a:effectRef>
-          <a:fontRef idx="minor">
-            <a:schemeClr val="lt1"/>
-          </a:fontRef>
-        </p:style>
-        <p:txBody>
-          <a:bodyPr rtlCol="0" anchor="ctr"/>
-          <a:lstStyle/>
-          <a:p>
-            <a:pPr algn="ctr"/>
-          </a:p>
-        </p:txBody>
-      </p:sp>
-      <p:sp>
-        <p:nvSpPr>
-          <p:cNvPr id="7" name="Rounded Rectangle 6"/>
-          <p:cNvSpPr/>
-          <p:nvPr/>
-        </p:nvSpPr>
-        <p:spPr>
-          <a:xfrm>
-            <a:off x="5039998" y="936000"/>
-            <a:ext cx="2106000" cy="900000"/>
-          </a:xfrm>
-          <a:prstGeom prst="roundRect">
-            <a:avLst/>
-          </a:prstGeom>
-          <a:solidFill>
-            <a:srgbClr val="B45F06"/>
-          </a:solidFill>
-          <a:ln w="9525">
-            <a:solidFill>
-              <a:srgbClr val="C6CCD8"/>
-            </a:solidFill>
-          </a:ln>
-        </p:spPr>
-        <p:style>
-          <a:lnRef idx="1">
-            <a:schemeClr val="accent1"/>
-          </a:lnRef>
-          <a:fillRef idx="3">
-            <a:schemeClr val="accent1"/>
-          </a:fillRef>
-          <a:effectRef idx="2">
-            <a:schemeClr val="accent1"/>
-          </a:effectRef>
-          <a:fontRef idx="minor">
-            <a:schemeClr val="lt1"/>
-          </a:fontRef>
-        </p:style>
-        <p:txBody>
-          <a:bodyPr rtlCol="0" anchor="ctr" wrap="square" lIns="36000" rIns="36000" tIns="21600" bIns="21600"/>
-          <a:lstStyle/>
-          <a:p>
-            <a:pPr algn="ctr"/>
-            <a:r>
-              <a:rPr sz="1200" b="1">
-                <a:solidFill>
-                  <a:srgbClr val="FFFFFF"/>
-                </a:solidFill>
-                <a:latin typeface="맑은 고딕"/>
-              </a:rPr>
-              <a:t>③ 정책 추론 연결</a:t>
-            </a:r>
-          </a:p>
-          <a:p>
-            <a:pPr algn="ctr"/>
-            <a:r>
-              <a:rPr sz="1000" b="0">
-                <a:solidFill>
-                  <a:srgbClr val="FFFFFF"/>
-                </a:solidFill>
-                <a:latin typeface="맑은 고딕"/>
-              </a:rPr>
-              <a:t>컨테이너 ACT 체크포인트</a:t>
-            </a:r>
-          </a:p>
-          <a:p>
-            <a:pPr algn="ctr"/>
-            <a:r>
-              <a:rPr sz="1000" b="0">
-                <a:solidFill>
-                  <a:srgbClr val="FFFFFF"/>
-                </a:solidFill>
-                <a:latin typeface="맑은 고딕"/>
-              </a:rPr>
-              <a:t>↔ 호스트 Isaac 브릿지</a:t>
-            </a:r>
-          </a:p>
-        </p:txBody>
-      </p:sp>
-      <p:sp>
-        <p:nvSpPr>
-          <p:cNvPr id="8" name="Right Arrow 7"/>
-          <p:cNvSpPr/>
-          <p:nvPr/>
-        </p:nvSpPr>
-        <p:spPr>
-          <a:xfrm>
-            <a:off x="7145998" y="1296000"/>
-            <a:ext cx="251999" cy="180000"/>
-          </a:xfrm>
-          <a:prstGeom prst="rightArrow">
-            <a:avLst/>
-          </a:prstGeom>
-          <a:solidFill>
-            <a:srgbClr val="626B78"/>
-          </a:solidFill>
-          <a:ln>
-            <a:noFill/>
-          </a:ln>
-        </p:spPr>
-        <p:style>
-          <a:lnRef idx="1">
-            <a:schemeClr val="accent1"/>
-          </a:lnRef>
-          <a:fillRef idx="3">
-            <a:schemeClr val="accent1"/>
-          </a:fillRef>
-          <a:effectRef idx="2">
-            <a:schemeClr val="accent1"/>
-          </a:effectRef>
-          <a:fontRef idx="minor">
-            <a:schemeClr val="lt1"/>
-          </a:fontRef>
-        </p:style>
-        <p:txBody>
-          <a:bodyPr rtlCol="0" anchor="ctr"/>
-          <a:lstStyle/>
-          <a:p>
-            <a:pPr algn="ctr"/>
-          </a:p>
-        </p:txBody>
-      </p:sp>
-      <p:sp>
-        <p:nvSpPr>
-          <p:cNvPr id="9" name="Rounded Rectangle 8"/>
-          <p:cNvSpPr/>
-          <p:nvPr/>
-        </p:nvSpPr>
-        <p:spPr>
-          <a:xfrm>
-            <a:off x="7397997" y="936000"/>
-            <a:ext cx="2106000" cy="900000"/>
-          </a:xfrm>
-          <a:prstGeom prst="roundRect">
-            <a:avLst/>
-          </a:prstGeom>
-          <a:solidFill>
-            <a:srgbClr val="2F3D9E"/>
-          </a:solidFill>
-          <a:ln w="9525">
-            <a:solidFill>
-              <a:srgbClr val="C6CCD8"/>
-            </a:solidFill>
-          </a:ln>
-        </p:spPr>
-        <p:style>
-          <a:lnRef idx="1">
-            <a:schemeClr val="accent1"/>
-          </a:lnRef>
-          <a:fillRef idx="3">
-            <a:schemeClr val="accent1"/>
-          </a:fillRef>
-          <a:effectRef idx="2">
-            <a:schemeClr val="accent1"/>
-          </a:effectRef>
-          <a:fontRef idx="minor">
-            <a:schemeClr val="lt1"/>
-          </a:fontRef>
-        </p:style>
-        <p:txBody>
-          <a:bodyPr rtlCol="0" anchor="ctr" wrap="square" lIns="36000" rIns="36000" tIns="21600" bIns="21600"/>
-          <a:lstStyle/>
-          <a:p>
-            <a:pPr algn="ctr"/>
-            <a:r>
-              <a:rPr sz="1200" b="1">
-                <a:solidFill>
-                  <a:srgbClr val="FFFFFF"/>
-                </a:solidFill>
-                <a:latin typeface="맑은 고딕"/>
-              </a:rPr>
-              <a:t>④ 실행·평가</a:t>
-            </a:r>
-          </a:p>
-          <a:p>
-            <a:pPr algn="ctr"/>
-            <a:r>
-              <a:rPr sz="1000" b="0">
-                <a:solidFill>
-                  <a:srgbClr val="FFFFFF"/>
-                </a:solidFill>
-                <a:latin typeface="맑은 고딕"/>
-              </a:rPr>
-              <a:t>성공률 · 오차</a:t>
-            </a:r>
-          </a:p>
-          <a:p>
-            <a:pPr algn="ctr"/>
-            <a:r>
-              <a:rPr sz="1000" b="0">
-                <a:solidFill>
-                  <a:srgbClr val="FFFFFF"/>
-                </a:solidFill>
-                <a:latin typeface="맑은 고딕"/>
-              </a:rPr>
-              <a:t>vs open-loop 대비</a:t>
-            </a:r>
-          </a:p>
-        </p:txBody>
-      </p:sp>
-      <p:sp>
-        <p:nvSpPr>
-          <p:cNvPr id="10" name="Right Arrow 9"/>
-          <p:cNvSpPr/>
-          <p:nvPr/>
-        </p:nvSpPr>
-        <p:spPr>
-          <a:xfrm>
-            <a:off x="9503997" y="1296000"/>
-            <a:ext cx="251999" cy="180000"/>
-          </a:xfrm>
-          <a:prstGeom prst="rightArrow">
-            <a:avLst/>
-          </a:prstGeom>
-          <a:solidFill>
-            <a:srgbClr val="626B78"/>
-          </a:solidFill>
-          <a:ln>
-            <a:noFill/>
-          </a:ln>
-        </p:spPr>
-        <p:style>
-          <a:lnRef idx="1">
-            <a:schemeClr val="accent1"/>
-          </a:lnRef>
-          <a:fillRef idx="3">
-            <a:schemeClr val="accent1"/>
-          </a:fillRef>
-          <a:effectRef idx="2">
-            <a:schemeClr val="accent1"/>
-          </a:effectRef>
-          <a:fontRef idx="minor">
-            <a:schemeClr val="lt1"/>
-          </a:fontRef>
-        </p:style>
-        <p:txBody>
-          <a:bodyPr rtlCol="0" anchor="ctr"/>
-          <a:lstStyle/>
-          <a:p>
-            <a:pPr algn="ctr"/>
-          </a:p>
-        </p:txBody>
-      </p:sp>
-      <p:sp>
-        <p:nvSpPr>
-          <p:cNvPr id="11" name="Rounded Rectangle 10"/>
-          <p:cNvSpPr/>
-          <p:nvPr/>
-        </p:nvSpPr>
-        <p:spPr>
-          <a:xfrm>
-            <a:off x="9755996" y="936000"/>
-            <a:ext cx="2106000" cy="900000"/>
-          </a:xfrm>
-          <a:prstGeom prst="roundRect">
-            <a:avLst/>
-          </a:prstGeom>
-          <a:solidFill>
-            <a:srgbClr val="1F6B4A"/>
-          </a:solidFill>
-          <a:ln w="9525">
-            <a:solidFill>
-              <a:srgbClr val="C6CCD8"/>
-            </a:solidFill>
-          </a:ln>
-        </p:spPr>
-        <p:style>
-          <a:lnRef idx="1">
-            <a:schemeClr val="accent1"/>
-          </a:lnRef>
-          <a:fillRef idx="3">
-            <a:schemeClr val="accent1"/>
-          </a:fillRef>
-          <a:effectRef idx="2">
-            <a:schemeClr val="accent1"/>
-          </a:effectRef>
-          <a:fontRef idx="minor">
-            <a:schemeClr val="lt1"/>
-          </a:fontRef>
-        </p:style>
-        <p:txBody>
-          <a:bodyPr rtlCol="0" anchor="ctr" wrap="square" lIns="36000" rIns="36000" tIns="21600" bIns="21600"/>
-          <a:lstStyle/>
-          <a:p>
-            <a:pPr algn="ctr"/>
-            <a:r>
-              <a:rPr sz="1200" b="1">
-                <a:solidFill>
-                  <a:srgbClr val="FFFFFF"/>
-                </a:solidFill>
-                <a:latin typeface="맑은 고딕"/>
-              </a:rPr>
-              <a:t>⑤ 갭 정량화</a:t>
-            </a:r>
-          </a:p>
-          <a:p>
-            <a:pPr algn="ctr"/>
-            <a:r>
-              <a:rPr sz="1000" b="0">
-                <a:solidFill>
-                  <a:srgbClr val="FFFFFF"/>
-                </a:solidFill>
-                <a:latin typeface="맑은 고딕"/>
-              </a:rPr>
-              <a:t>실패 모드 분석</a:t>
-            </a:r>
-          </a:p>
-          <a:p>
-            <a:pPr algn="ctr"/>
-            <a:r>
-              <a:rPr sz="1000" b="0">
-                <a:solidFill>
-                  <a:srgbClr val="FFFFFF"/>
-                </a:solidFill>
-                <a:latin typeface="맑은 고딕"/>
-              </a:rPr>
-              <a:t>→ 5-4 여부 결정</a:t>
-            </a:r>
-          </a:p>
-        </p:txBody>
-      </p:sp>
-      <p:sp>
-        <p:nvSpPr>
-          <p:cNvPr id="12" name="TextBox 11"/>
+              <a:t>왜 카메라를 설치했나 — 목적과 검사 가능 범위</a:t>
+            </a:r>
+          </a:p>
+        </p:txBody>
+      </p:sp>
+      <p:sp>
+        <p:nvSpPr>
+          <p:cNvPr id="3" name="TextBox 2"/>
           <p:cNvSpPr txBox="1"/>
           <p:nvPr/>
         </p:nvSpPr>
         <p:spPr>
           <a:xfrm>
-            <a:off x="324000" y="2052000"/>
-            <a:ext cx="11520000" cy="2520000"/>
+            <a:off x="324000" y="864000"/>
+            <a:ext cx="11520000" cy="1512000"/>
           </a:xfrm>
           <a:prstGeom prst="rect">
             <a:avLst/>
@@ -5623,13 +5064,13 @@
               </a:spcAft>
             </a:pPr>
             <a:r>
-              <a:rPr sz="1400" b="1">
+              <a:rPr sz="1450" b="1">
                 <a:solidFill>
                   <a:srgbClr val="15181D"/>
                 </a:solidFill>
                 <a:latin typeface="맑은 고딕"/>
               </a:rPr>
-              <a:t>▪  구체 시작점: closed_loop_m1013.py 신규 작성 — replay_isaac.py 의 씬 조립부 재사용 + cameras_v6match.json 로드</a:t>
+              <a:t>▪  ① 정책 관측 확보 — ACT 정책의 입력은 손목캠·정면캠 이미지 2장. sim 안에서 정책을 구동하려면 매 스텝 관측 화면을 렌더로 생성해야 함</a:t>
             </a:r>
           </a:p>
           <a:p>
@@ -5645,7 +5086,7 @@
                 </a:solidFill>
                 <a:latin typeface="맑은 고딕"/>
               </a:rPr>
-              <a:t>–  관측 규약은 학습과 동일하게: observation.images.camera1=손목캠, camera2=정면캠, state=action[t−1] 규약 확인 필요</a:t>
+              <a:t>–  기존 검증(open-loop 평가 · 정책 궤적 물리 재생)은 모두 실제 OMX 영상을 먹인 것 — 정책이 sim 을 본 적은 한 번도 없었음. 지금까지 시뮬레이션은 '재생 장치'였음</a:t>
             </a:r>
           </a:p>
           <a:p>
@@ -5655,13 +5096,13 @@
               </a:spcAft>
             </a:pPr>
             <a:r>
-              <a:rPr sz="1400" b="1">
+              <a:rPr sz="1450" b="1">
                 <a:solidFill>
                   <a:srgbClr val="15181D"/>
                 </a:solidFill>
                 <a:latin typeface="맑은 고딕"/>
               </a:rPr>
-              <a:t>▪  고려사항 (착수 전 결정할 것):</a:t>
+              <a:t>▪  ② 실물 준비 자산 확보 — 확정 파라미터·탐색 도구는 실물 손목캠 부품/마운트 선정 시 '해당 FOV·위치에서 시야가 충분한가'를 프린팅 전에 검증하는 데 재사용</a:t>
             </a:r>
           </a:p>
           <a:p>
@@ -5677,70 +5118,22 @@
                 </a:solidFill>
                 <a:latin typeface="맑은 고딕"/>
               </a:rPr>
-              <a:t>–  ㉠ 추론 위치: 정책은 컨테이너(lerobot·GPU), Isaac 은 호스트 — 파일 핑퐁(느림) vs ZMQ/소켓 브릿지(권장) vs 호스트에 lerobot 설치</a:t>
-            </a:r>
-          </a:p>
-          <a:p>
-            <a:pPr lvl="1">
-              <a:spcAft>
-                <a:spcPts val="600"/>
-              </a:spcAft>
-            </a:pPr>
-            <a:r>
-              <a:rPr sz="1300" b="0">
-                <a:solidFill>
-                  <a:srgbClr val="15181D"/>
-                </a:solidFill>
-                <a:latin typeface="맑은 고딕"/>
-              </a:rPr>
-              <a:t>–  ㉡ 실행 방식: 30Hz 매 스텝 추론 불필요 — ACT 청크(예: 100프레임) 단위 실행 + 재계획 주기 결정</a:t>
-            </a:r>
-          </a:p>
-          <a:p>
-            <a:pPr lvl="1">
-              <a:spcAft>
-                <a:spcPts val="600"/>
-              </a:spcAft>
-            </a:pPr>
-            <a:r>
-              <a:rPr sz="1300" b="0">
-                <a:solidFill>
-                  <a:srgbClr val="15181D"/>
-                </a:solidFill>
-                <a:latin typeface="맑은 고딕"/>
-              </a:rPr>
-              <a:t>–  ㉢ 렌더 속도: 두 카메라 렌더 포함 스텝 속도 실측 → 실시간 불가 시 sim 시간 기준으로 평가 (물리 정합성 유지)</a:t>
-            </a:r>
-          </a:p>
-          <a:p>
-            <a:pPr lvl="1">
-              <a:spcAft>
-                <a:spcPts val="600"/>
-              </a:spcAft>
-            </a:pPr>
-            <a:r>
-              <a:rPr sz="1300" b="0">
-                <a:solidFill>
-                  <a:srgbClr val="15181D"/>
-                </a:solidFill>
-                <a:latin typeface="맑은 고딕"/>
-              </a:rPr>
-              <a:t>–  ㉣ 평가 설계: 동일 에피소드 GT 재생(6/8 성공)과 같은 8ep 로 A/B — '구도 정합 완료' 덕에 실패 원인을 도메인 갭으로 귀속 가능</a:t>
+              <a:t>–  관측 → 추론 → 관절명령 파이프라인 구조는 실물에서도 동일 — 도착 후 시간 절약</a:t>
             </a:r>
           </a:p>
         </p:txBody>
       </p:sp>
       <p:graphicFrame>
         <p:nvGraphicFramePr>
-          <p:cNvPr id="13" name="Table 12"/>
+          <p:cNvPr id="4" name="Table 3"/>
           <p:cNvGraphicFramePr>
             <a:graphicFrameLocks noGrp="1"/>
           </p:cNvGraphicFramePr>
           <p:nvPr/>
         </p:nvGraphicFramePr>
         <p:xfrm>
-          <a:off x="324000" y="4896000"/>
-          <a:ext cx="11555999" cy="1296000"/>
+          <a:off x="324000" y="2592000"/>
+          <a:ext cx="11555999" cy="2015996"/>
         </p:xfrm>
         <a:graphic>
           <a:graphicData uri="http://schemas.openxmlformats.org/drawingml/2006/table">
@@ -5749,10 +5142,12 @@
                 <a:tableStyleId>{5C22544A-7EE6-4342-B048-85BDC9FD1C3A}</a:tableStyleId>
               </a:tblPr>
               <a:tblGrid>
-                <a:gridCol w="2731418"/>
-                <a:gridCol w="8824581"/>
+                <a:gridCol w="1785927"/>
+                <a:gridCol w="2311200"/>
+                <a:gridCol w="1996036"/>
+                <a:gridCol w="5462836"/>
               </a:tblGrid>
-              <a:tr h="432000">
+              <a:tr h="503999">
                 <a:tc>
                   <a:txBody>
                     <a:bodyPr/>
@@ -5765,7 +5160,7 @@
                           </a:solidFill>
                           <a:latin typeface="맑은 고딕"/>
                         </a:rPr>
-                        <a:t>병행·후속 (0820 계획 유지)</a:t>
+                        <a:t>시점</a:t>
                       </a:r>
                     </a:p>
                   </a:txBody>
@@ -5787,7 +5182,7 @@
                           </a:solidFill>
                           <a:latin typeface="맑은 고딕"/>
                         </a:rPr>
-                        <a:t>내용</a:t>
+                        <a:t>이미지 출처</a:t>
                       </a:r>
                     </a:p>
                   </a:txBody>
@@ -5797,8 +5192,52 @@
                     </a:solidFill>
                   </a:tcPr>
                 </a:tc>
+                <a:tc>
+                  <a:txBody>
+                    <a:bodyPr/>
+                    <a:lstStyle/>
+                    <a:p>
+                      <a:r>
+                        <a:rPr sz="1200" b="1">
+                          <a:solidFill>
+                            <a:srgbClr val="FFFFFF"/>
+                          </a:solidFill>
+                          <a:latin typeface="맑은 고딕"/>
+                        </a:rPr>
+                        <a:t>로봇</a:t>
+                      </a:r>
+                    </a:p>
+                  </a:txBody>
+                  <a:tcPr marL="57600" marR="57600" marT="18000" marB="18000" anchor="ctr">
+                    <a:solidFill>
+                      <a:srgbClr val="2F3D9E"/>
+                    </a:solidFill>
+                  </a:tcPr>
+                </a:tc>
+                <a:tc>
+                  <a:txBody>
+                    <a:bodyPr/>
+                    <a:lstStyle/>
+                    <a:p>
+                      <a:r>
+                        <a:rPr sz="1200" b="1">
+                          <a:solidFill>
+                            <a:srgbClr val="FFFFFF"/>
+                          </a:solidFill>
+                          <a:latin typeface="맑은 고딕"/>
+                        </a:rPr>
+                        <a:t>무엇을 알 수 있나</a:t>
+                      </a:r>
+                    </a:p>
+                  </a:txBody>
+                  <a:tcPr marL="57600" marR="57600" marT="18000" marB="18000" anchor="ctr">
+                    <a:solidFill>
+                      <a:srgbClr val="2F3D9E"/>
+                    </a:solidFill>
+                  </a:tcPr>
+                </a:tc>
               </a:tr>
-              <a:tr h="432000">
+              <a:tr h="503999">
                 <a:tc>
                   <a:txBody>
                     <a:bodyPr/>
@@ -5811,7 +5250,7 @@
                           </a:solidFill>
                           <a:latin typeface="맑은 고딕"/>
                         </a:rPr>
-                        <a:t>5-4 co-training A/B</a:t>
+                        <a:t>지금까지 (STEP 4)</a:t>
                       </a:r>
                     </a:p>
                   </a:txBody>
@@ -5833,7 +5272,7 @@
                           </a:solidFill>
                           <a:latin typeface="맑은 고딕"/>
                         </a:rPr>
-                        <a:t>5-3 갭이 크면: 159ep 를 확정 카메라로 재렌더 → sim 혼합학습 이득 검증 후 채택</a:t>
+                        <a:t>실제 OMX 영상 파일</a:t>
                       </a:r>
                     </a:p>
                   </a:txBody>
@@ -5843,8 +5282,52 @@
                     </a:solidFill>
                   </a:tcPr>
                 </a:tc>
+                <a:tc>
+                  <a:txBody>
+                    <a:bodyPr/>
+                    <a:lstStyle/>
+                    <a:p>
+                      <a:r>
+                        <a:rPr sz="1200" b="0">
+                          <a:solidFill>
+                            <a:srgbClr val="15181D"/>
+                          </a:solidFill>
+                          <a:latin typeface="맑은 고딕"/>
+                        </a:rPr>
+                        <a:t>없음 (예측만 비교)</a:t>
+                      </a:r>
+                    </a:p>
+                  </a:txBody>
+                  <a:tcPr marL="57600" marR="57600" marT="18000" marB="18000" anchor="ctr">
+                    <a:solidFill>
+                      <a:srgbClr val="FFFFFF"/>
+                    </a:solidFill>
+                  </a:tcPr>
+                </a:tc>
+                <a:tc>
+                  <a:txBody>
+                    <a:bodyPr/>
+                    <a:lstStyle/>
+                    <a:p>
+                      <a:r>
+                        <a:rPr sz="1200" b="0">
+                          <a:solidFill>
+                            <a:srgbClr val="15181D"/>
+                          </a:solidFill>
+                          <a:latin typeface="맑은 고딕"/>
+                        </a:rPr>
+                        <a:t>정책이 학습 분포를 재현하는가 (open-loop 0.62~0.67°)</a:t>
+                      </a:r>
+                    </a:p>
+                  </a:txBody>
+                  <a:tcPr marL="57600" marR="57600" marT="18000" marB="18000" anchor="ctr">
+                    <a:solidFill>
+                      <a:srgbClr val="FFFFFF"/>
+                    </a:solidFill>
+                  </a:tcPr>
+                </a:tc>
               </a:tr>
-              <a:tr h="432000">
+              <a:tr h="503999">
                 <a:tc>
                   <a:txBody>
                     <a:bodyPr/>
@@ -5857,7 +5340,7 @@
                           </a:solidFill>
                           <a:latin typeface="맑은 고딕"/>
                         </a:rPr>
-                        <a:t>실기 준비</a:t>
+                        <a:t>STEP 5-3 (가능해짐)</a:t>
                       </a:r>
                     </a:p>
                   </a:txBody>
@@ -5873,19 +5356,153 @@
                     <a:lstStyle/>
                     <a:p>
                       <a:r>
+                        <a:rPr sz="1200" b="1">
+                          <a:solidFill>
+                            <a:srgbClr val="15181D"/>
+                          </a:solidFill>
+                          <a:latin typeface="맑은 고딕"/>
+                        </a:rPr>
+                        <a:t>Isaac 렌더 ← 오늘 작업</a:t>
+                      </a:r>
+                    </a:p>
+                  </a:txBody>
+                  <a:tcPr marL="57600" marR="57600" marT="18000" marB="18000" anchor="ctr">
+                    <a:solidFill>
+                      <a:srgbClr val="EDEFF3"/>
+                    </a:solidFill>
+                  </a:tcPr>
+                </a:tc>
+                <a:tc>
+                  <a:txBody>
+                    <a:bodyPr/>
+                    <a:lstStyle/>
+                    <a:p>
+                      <a:r>
                         <a:rPr sz="1200" b="0">
                           <a:solidFill>
                             <a:srgbClr val="15181D"/>
                           </a:solidFill>
                           <a:latin typeface="맑은 고딕"/>
                         </a:rPr>
-                        <a:t>TCP 0.12m 잠정값 (LEHR 실측 후 재변환 1분+재학습 ~3h) · 어태치먼트 연질 팁 · 손목캠 마운트 설계에 오늘 오프셋(−39,−45,+50mm) 참조 가능</a:t>
+                        <a:t>Isaac 안 가상 M1013</a:t>
                       </a:r>
                     </a:p>
                   </a:txBody>
                   <a:tcPr marL="57600" marR="57600" marT="18000" marB="18000" anchor="ctr">
                     <a:solidFill>
                       <a:srgbClr val="EDEFF3"/>
+                    </a:solidFill>
+                  </a:tcPr>
+                </a:tc>
+                <a:tc>
+                  <a:txBody>
+                    <a:bodyPr/>
+                    <a:lstStyle/>
+                    <a:p>
+                      <a:r>
+                        <a:rPr sz="1200" b="1">
+                          <a:solidFill>
+                            <a:srgbClr val="15181D"/>
+                          </a:solidFill>
+                          <a:latin typeface="맑은 고딕"/>
+                        </a:rPr>
+                        <a:t>예상 못 한 상황에 반응하는가 — 큐브 위치 변경 · 파지 어긋남 복구 · 초기자세 교란</a:t>
+                      </a:r>
+                    </a:p>
+                  </a:txBody>
+                  <a:tcPr marL="57600" marR="57600" marT="18000" marB="18000" anchor="ctr">
+                    <a:solidFill>
+                      <a:srgbClr val="EDEFF3"/>
+                    </a:solidFill>
+                  </a:tcPr>
+                </a:tc>
+              </a:tr>
+              <a:tr h="503999">
+                <a:tc>
+                  <a:txBody>
+                    <a:bodyPr/>
+                    <a:lstStyle/>
+                    <a:p>
+                      <a:r>
+                        <a:rPr sz="1200" b="0">
+                          <a:solidFill>
+                            <a:srgbClr val="15181D"/>
+                          </a:solidFill>
+                          <a:latin typeface="맑은 고딕"/>
+                        </a:rPr>
+                        <a:t>로봇 도착 후</a:t>
+                      </a:r>
+                    </a:p>
+                  </a:txBody>
+                  <a:tcPr marL="57600" marR="57600" marT="18000" marB="18000" anchor="ctr">
+                    <a:solidFill>
+                      <a:srgbClr val="FFFFFF"/>
+                    </a:solidFill>
+                  </a:tcPr>
+                </a:tc>
+                <a:tc>
+                  <a:txBody>
+                    <a:bodyPr/>
+                    <a:lstStyle/>
+                    <a:p>
+                      <a:r>
+                        <a:rPr sz="1200" b="0">
+                          <a:solidFill>
+                            <a:srgbClr val="15181D"/>
+                          </a:solidFill>
+                          <a:latin typeface="맑은 고딕"/>
+                        </a:rPr>
+                        <a:t>실물 카메라 사진</a:t>
+                      </a:r>
+                    </a:p>
+                  </a:txBody>
+                  <a:tcPr marL="57600" marR="57600" marT="18000" marB="18000" anchor="ctr">
+                    <a:solidFill>
+                      <a:srgbClr val="FFFFFF"/>
+                    </a:solidFill>
+                  </a:tcPr>
+                </a:tc>
+                <a:tc>
+                  <a:txBody>
+                    <a:bodyPr/>
+                    <a:lstStyle/>
+                    <a:p>
+                      <a:r>
+                        <a:rPr sz="1200" b="0">
+                          <a:solidFill>
+                            <a:srgbClr val="15181D"/>
+                          </a:solidFill>
+                          <a:latin typeface="맑은 고딕"/>
+                        </a:rPr>
+                        <a:t>진짜 M1013</a:t>
+                      </a:r>
+                    </a:p>
+                  </a:txBody>
+                  <a:tcPr marL="57600" marR="57600" marT="18000" marB="18000" anchor="ctr">
+                    <a:solidFill>
+                      <a:srgbClr val="FFFFFF"/>
+                    </a:solidFill>
+                  </a:tcPr>
+                </a:tc>
+                <a:tc>
+                  <a:txBody>
+                    <a:bodyPr/>
+                    <a:lstStyle/>
+                    <a:p>
+                      <a:r>
+                        <a:rPr sz="1200" b="0">
+                          <a:solidFill>
+                            <a:srgbClr val="15181D"/>
+                          </a:solidFill>
+                          <a:latin typeface="맑은 고딕"/>
+                        </a:rPr>
+                        <a:t>실제 성능 (Isaac 은 루프에서 빠짐)</a:t>
+                      </a:r>
+                    </a:p>
+                  </a:txBody>
+                  <a:tcPr marL="57600" marR="57600" marT="18000" marB="18000" anchor="ctr">
+                    <a:solidFill>
+                      <a:srgbClr val="FFFFFF"/>
                     </a:solidFill>
                   </a:tcPr>
                 </a:tc>
@@ -5896,7 +5513,94 @@
       </p:graphicFrame>
       <p:sp>
         <p:nvSpPr>
-          <p:cNvPr id="14" name="TextBox 13"/>
+          <p:cNvPr id="5" name="TextBox 4"/>
+          <p:cNvSpPr txBox="1"/>
+          <p:nvPr/>
+        </p:nvSpPr>
+        <p:spPr>
+          <a:xfrm>
+            <a:off x="324000" y="4752000"/>
+            <a:ext cx="11520000" cy="1584000"/>
+          </a:xfrm>
+          <a:prstGeom prst="rect">
+            <a:avLst/>
+          </a:prstGeom>
+          <a:noFill/>
+        </p:spPr>
+        <p:txBody>
+          <a:bodyPr wrap="square">
+            <a:spAutoFit/>
+          </a:bodyPr>
+          <a:lstStyle/>
+          <a:p>
+            <a:pPr>
+              <a:spcAft>
+                <a:spcPts val="600"/>
+              </a:spcAft>
+            </a:pPr>
+            <a:r>
+              <a:rPr sz="1400" b="1">
+                <a:solidFill>
+                  <a:srgbClr val="B45F06"/>
+                </a:solidFill>
+                <a:latin typeface="맑은 고딕"/>
+              </a:rPr>
+              <a:t>▪  한계 — 결론이 비대칭임을 명시할 것:</a:t>
+            </a:r>
+          </a:p>
+          <a:p>
+            <a:pPr lvl="1">
+              <a:spcAft>
+                <a:spcPts val="600"/>
+              </a:spcAft>
+            </a:pPr>
+            <a:r>
+              <a:rPr sz="1300" b="0">
+                <a:solidFill>
+                  <a:srgbClr val="15181D"/>
+                </a:solidFill>
+                <a:latin typeface="맑은 고딕"/>
+              </a:rPr>
+              <a:t>–  sim 에서 성공해도 실물 성공의 보장이 아님 (렌더 화면 ≠ 실물 사진)</a:t>
+            </a:r>
+          </a:p>
+          <a:p>
+            <a:pPr lvl="1">
+              <a:spcAft>
+                <a:spcPts val="600"/>
+              </a:spcAft>
+            </a:pPr>
+            <a:r>
+              <a:rPr sz="1300" b="0">
+                <a:solidFill>
+                  <a:srgbClr val="15181D"/>
+                </a:solidFill>
+                <a:latin typeface="맑은 고딕"/>
+              </a:rPr>
+              <a:t>–  sim 에서 실패해도 정책 결함인지 sim 이 안 닮은 탓인지 구분 불가</a:t>
+            </a:r>
+          </a:p>
+          <a:p>
+            <a:pPr lvl="1">
+              <a:spcAft>
+                <a:spcPts val="600"/>
+              </a:spcAft>
+            </a:pPr>
+            <a:r>
+              <a:rPr sz="1300" b="1">
+                <a:solidFill>
+                  <a:srgbClr val="15181D"/>
+                </a:solidFill>
+                <a:latin typeface="맑은 고딕"/>
+              </a:rPr>
+              <a:t>–  따라서 closed-loop 성공률 숫자 자체의 증명력은 약함 — 가치는 '파이프라인 리허설'과 '반응성 관찰'에 있음</a:t>
+            </a:r>
+          </a:p>
+        </p:txBody>
+      </p:sp>
+      <p:sp>
+        <p:nvSpPr>
+          <p:cNvPr id="6" name="TextBox 5"/>
           <p:cNvSpPr txBox="1"/>
           <p:nvPr/>
         </p:nvSpPr>
@@ -5993,7 +5697,2454 @@
                 </a:solidFill>
                 <a:latin typeface="맑은 고딕"/>
               </a:rPr>
-              <a:t>09 참조  </a:t>
+              <a:t>09 실물 연결  </a:t>
+            </a:r>
+            <a:r>
+              <a:rPr sz="2100" b="1">
+                <a:solidFill>
+                  <a:srgbClr val="FFFFFF"/>
+                </a:solidFill>
+                <a:latin typeface="맑은 고딕"/>
+              </a:rPr>
+              <a:t>가상 카메라와 실물 카메라는 어떻게 이어지나</a:t>
+            </a:r>
+          </a:p>
+        </p:txBody>
+      </p:sp>
+      <p:sp>
+        <p:nvSpPr>
+          <p:cNvPr id="3" name="TextBox 2"/>
+          <p:cNvSpPr txBox="1"/>
+          <p:nvPr/>
+        </p:nvSpPr>
+        <p:spPr>
+          <a:xfrm>
+            <a:off x="324000" y="827999"/>
+            <a:ext cx="11520000" cy="288000"/>
+          </a:xfrm>
+          <a:prstGeom prst="rect">
+            <a:avLst/>
+          </a:prstGeom>
+          <a:noFill/>
+        </p:spPr>
+        <p:txBody>
+          <a:bodyPr wrap="square">
+            <a:spAutoFit/>
+          </a:bodyPr>
+          <a:lstStyle/>
+          <a:p>
+            <a:r>
+              <a:rPr sz="1500" b="1">
+                <a:solidFill>
+                  <a:srgbClr val="15181D"/>
+                </a:solidFill>
+                <a:latin typeface="맑은 고딕"/>
+              </a:rPr>
+              <a:t>정책에는 '640×480 이미지를 꽂는 구멍'이 2개 — 무엇을 꽂든 정책은 구분하지 않음</a:t>
+            </a:r>
+          </a:p>
+        </p:txBody>
+      </p:sp>
+      <p:sp>
+        <p:nvSpPr>
+          <p:cNvPr id="4" name="TextBox 3"/>
+          <p:cNvSpPr txBox="1"/>
+          <p:nvPr/>
+        </p:nvSpPr>
+        <p:spPr>
+          <a:xfrm>
+            <a:off x="324000" y="1152000"/>
+            <a:ext cx="2160000" cy="432000"/>
+          </a:xfrm>
+          <a:prstGeom prst="rect">
+            <a:avLst/>
+          </a:prstGeom>
+          <a:noFill/>
+        </p:spPr>
+        <p:txBody>
+          <a:bodyPr wrap="square">
+            <a:spAutoFit/>
+          </a:bodyPr>
+          <a:lstStyle/>
+          <a:p>
+            <a:r>
+              <a:rPr sz="1300" b="1">
+                <a:solidFill>
+                  <a:srgbClr val="2F3D9E"/>
+                </a:solidFill>
+                <a:latin typeface="맑은 고딕"/>
+              </a:rPr>
+              <a:t>지금 (로봇 없음)</a:t>
+            </a:r>
+          </a:p>
+        </p:txBody>
+      </p:sp>
+      <p:sp>
+        <p:nvSpPr>
+          <p:cNvPr id="5" name="Rounded Rectangle 4"/>
+          <p:cNvSpPr/>
+          <p:nvPr/>
+        </p:nvSpPr>
+        <p:spPr>
+          <a:xfrm>
+            <a:off x="324000" y="1440000"/>
+            <a:ext cx="2376000" cy="648000"/>
+          </a:xfrm>
+          <a:prstGeom prst="roundRect">
+            <a:avLst/>
+          </a:prstGeom>
+          <a:solidFill>
+            <a:srgbClr val="EDEFF3"/>
+          </a:solidFill>
+          <a:ln w="9525">
+            <a:solidFill>
+              <a:srgbClr val="C6CCD8"/>
+            </a:solidFill>
+          </a:ln>
+        </p:spPr>
+        <p:style>
+          <a:lnRef idx="1">
+            <a:schemeClr val="accent1"/>
+          </a:lnRef>
+          <a:fillRef idx="3">
+            <a:schemeClr val="accent1"/>
+          </a:fillRef>
+          <a:effectRef idx="2">
+            <a:schemeClr val="accent1"/>
+          </a:effectRef>
+          <a:fontRef idx="minor">
+            <a:schemeClr val="lt1"/>
+          </a:fontRef>
+        </p:style>
+        <p:txBody>
+          <a:bodyPr rtlCol="0" anchor="ctr" wrap="square" lIns="36000" rIns="36000" tIns="21600" bIns="21600"/>
+          <a:lstStyle/>
+          <a:p>
+            <a:pPr algn="ctr"/>
+            <a:r>
+              <a:rPr sz="1250" b="1">
+                <a:solidFill>
+                  <a:srgbClr val="15181D"/>
+                </a:solidFill>
+                <a:latin typeface="맑은 고딕"/>
+              </a:rPr>
+              <a:t>Isaac 렌더 이미지</a:t>
+            </a:r>
+          </a:p>
+          <a:p>
+            <a:pPr algn="ctr"/>
+            <a:r>
+              <a:rPr sz="1050" b="0">
+                <a:solidFill>
+                  <a:srgbClr val="15181D"/>
+                </a:solidFill>
+                <a:latin typeface="맑은 고딕"/>
+              </a:rPr>
+              <a:t>+ 관절 상태</a:t>
+            </a:r>
+          </a:p>
+        </p:txBody>
+      </p:sp>
+      <p:sp>
+        <p:nvSpPr>
+          <p:cNvPr id="6" name="Right Arrow 5"/>
+          <p:cNvSpPr/>
+          <p:nvPr/>
+        </p:nvSpPr>
+        <p:spPr>
+          <a:xfrm>
+            <a:off x="2736000" y="1674000"/>
+            <a:ext cx="251999" cy="180000"/>
+          </a:xfrm>
+          <a:prstGeom prst="rightArrow">
+            <a:avLst/>
+          </a:prstGeom>
+          <a:solidFill>
+            <a:srgbClr val="626B78"/>
+          </a:solidFill>
+          <a:ln>
+            <a:noFill/>
+          </a:ln>
+        </p:spPr>
+        <p:style>
+          <a:lnRef idx="1">
+            <a:schemeClr val="accent1"/>
+          </a:lnRef>
+          <a:fillRef idx="3">
+            <a:schemeClr val="accent1"/>
+          </a:fillRef>
+          <a:effectRef idx="2">
+            <a:schemeClr val="accent1"/>
+          </a:effectRef>
+          <a:fontRef idx="minor">
+            <a:schemeClr val="lt1"/>
+          </a:fontRef>
+        </p:style>
+        <p:txBody>
+          <a:bodyPr rtlCol="0" anchor="ctr"/>
+          <a:lstStyle/>
+          <a:p>
+            <a:pPr algn="ctr"/>
+          </a:p>
+        </p:txBody>
+      </p:sp>
+      <p:sp>
+        <p:nvSpPr>
+          <p:cNvPr id="7" name="Rounded Rectangle 6"/>
+          <p:cNvSpPr/>
+          <p:nvPr/>
+        </p:nvSpPr>
+        <p:spPr>
+          <a:xfrm>
+            <a:off x="3024000" y="1440000"/>
+            <a:ext cx="2376000" cy="648000"/>
+          </a:xfrm>
+          <a:prstGeom prst="roundRect">
+            <a:avLst/>
+          </a:prstGeom>
+          <a:solidFill>
+            <a:srgbClr val="2F3D9E"/>
+          </a:solidFill>
+          <a:ln w="9525">
+            <a:solidFill>
+              <a:srgbClr val="C6CCD8"/>
+            </a:solidFill>
+          </a:ln>
+        </p:spPr>
+        <p:style>
+          <a:lnRef idx="1">
+            <a:schemeClr val="accent1"/>
+          </a:lnRef>
+          <a:fillRef idx="3">
+            <a:schemeClr val="accent1"/>
+          </a:fillRef>
+          <a:effectRef idx="2">
+            <a:schemeClr val="accent1"/>
+          </a:effectRef>
+          <a:fontRef idx="minor">
+            <a:schemeClr val="lt1"/>
+          </a:fontRef>
+        </p:style>
+        <p:txBody>
+          <a:bodyPr rtlCol="0" anchor="ctr" wrap="square" lIns="36000" rIns="36000" tIns="21600" bIns="21600"/>
+          <a:lstStyle/>
+          <a:p>
+            <a:pPr algn="ctr"/>
+            <a:r>
+              <a:rPr sz="1250" b="1">
+                <a:solidFill>
+                  <a:srgbClr val="FFFFFF"/>
+                </a:solidFill>
+                <a:latin typeface="맑은 고딕"/>
+              </a:rPr>
+              <a:t>ACT 정책</a:t>
+            </a:r>
+          </a:p>
+        </p:txBody>
+      </p:sp>
+      <p:sp>
+        <p:nvSpPr>
+          <p:cNvPr id="8" name="Right Arrow 7"/>
+          <p:cNvSpPr/>
+          <p:nvPr/>
+        </p:nvSpPr>
+        <p:spPr>
+          <a:xfrm>
+            <a:off x="5436000" y="1674000"/>
+            <a:ext cx="251999" cy="180000"/>
+          </a:xfrm>
+          <a:prstGeom prst="rightArrow">
+            <a:avLst/>
+          </a:prstGeom>
+          <a:solidFill>
+            <a:srgbClr val="626B78"/>
+          </a:solidFill>
+          <a:ln>
+            <a:noFill/>
+          </a:ln>
+        </p:spPr>
+        <p:style>
+          <a:lnRef idx="1">
+            <a:schemeClr val="accent1"/>
+          </a:lnRef>
+          <a:fillRef idx="3">
+            <a:schemeClr val="accent1"/>
+          </a:fillRef>
+          <a:effectRef idx="2">
+            <a:schemeClr val="accent1"/>
+          </a:effectRef>
+          <a:fontRef idx="minor">
+            <a:schemeClr val="lt1"/>
+          </a:fontRef>
+        </p:style>
+        <p:txBody>
+          <a:bodyPr rtlCol="0" anchor="ctr"/>
+          <a:lstStyle/>
+          <a:p>
+            <a:pPr algn="ctr"/>
+          </a:p>
+        </p:txBody>
+      </p:sp>
+      <p:sp>
+        <p:nvSpPr>
+          <p:cNvPr id="9" name="Rounded Rectangle 8"/>
+          <p:cNvSpPr/>
+          <p:nvPr/>
+        </p:nvSpPr>
+        <p:spPr>
+          <a:xfrm>
+            <a:off x="5724000" y="1440000"/>
+            <a:ext cx="2376000" cy="648000"/>
+          </a:xfrm>
+          <a:prstGeom prst="roundRect">
+            <a:avLst/>
+          </a:prstGeom>
+          <a:solidFill>
+            <a:srgbClr val="EDEFF3"/>
+          </a:solidFill>
+          <a:ln w="9525">
+            <a:solidFill>
+              <a:srgbClr val="C6CCD8"/>
+            </a:solidFill>
+          </a:ln>
+        </p:spPr>
+        <p:style>
+          <a:lnRef idx="1">
+            <a:schemeClr val="accent1"/>
+          </a:lnRef>
+          <a:fillRef idx="3">
+            <a:schemeClr val="accent1"/>
+          </a:fillRef>
+          <a:effectRef idx="2">
+            <a:schemeClr val="accent1"/>
+          </a:effectRef>
+          <a:fontRef idx="minor">
+            <a:schemeClr val="lt1"/>
+          </a:fontRef>
+        </p:style>
+        <p:txBody>
+          <a:bodyPr rtlCol="0" anchor="ctr" wrap="square" lIns="36000" rIns="36000" tIns="21600" bIns="21600"/>
+          <a:lstStyle/>
+          <a:p>
+            <a:pPr algn="ctr"/>
+            <a:r>
+              <a:rPr sz="1250" b="1">
+                <a:solidFill>
+                  <a:srgbClr val="15181D"/>
+                </a:solidFill>
+                <a:latin typeface="맑은 고딕"/>
+              </a:rPr>
+              <a:t>관절 명령</a:t>
+            </a:r>
+          </a:p>
+        </p:txBody>
+      </p:sp>
+      <p:sp>
+        <p:nvSpPr>
+          <p:cNvPr id="10" name="Right Arrow 9"/>
+          <p:cNvSpPr/>
+          <p:nvPr/>
+        </p:nvSpPr>
+        <p:spPr>
+          <a:xfrm>
+            <a:off x="8136000" y="1674000"/>
+            <a:ext cx="251999" cy="180000"/>
+          </a:xfrm>
+          <a:prstGeom prst="rightArrow">
+            <a:avLst/>
+          </a:prstGeom>
+          <a:solidFill>
+            <a:srgbClr val="626B78"/>
+          </a:solidFill>
+          <a:ln>
+            <a:noFill/>
+          </a:ln>
+        </p:spPr>
+        <p:style>
+          <a:lnRef idx="1">
+            <a:schemeClr val="accent1"/>
+          </a:lnRef>
+          <a:fillRef idx="3">
+            <a:schemeClr val="accent1"/>
+          </a:fillRef>
+          <a:effectRef idx="2">
+            <a:schemeClr val="accent1"/>
+          </a:effectRef>
+          <a:fontRef idx="minor">
+            <a:schemeClr val="lt1"/>
+          </a:fontRef>
+        </p:style>
+        <p:txBody>
+          <a:bodyPr rtlCol="0" anchor="ctr"/>
+          <a:lstStyle/>
+          <a:p>
+            <a:pPr algn="ctr"/>
+          </a:p>
+        </p:txBody>
+      </p:sp>
+      <p:sp>
+        <p:nvSpPr>
+          <p:cNvPr id="11" name="Rounded Rectangle 10"/>
+          <p:cNvSpPr/>
+          <p:nvPr/>
+        </p:nvSpPr>
+        <p:spPr>
+          <a:xfrm>
+            <a:off x="8424000" y="1440000"/>
+            <a:ext cx="2376000" cy="648000"/>
+          </a:xfrm>
+          <a:prstGeom prst="roundRect">
+            <a:avLst/>
+          </a:prstGeom>
+          <a:solidFill>
+            <a:srgbClr val="EDEFF3"/>
+          </a:solidFill>
+          <a:ln w="9525">
+            <a:solidFill>
+              <a:srgbClr val="C6CCD8"/>
+            </a:solidFill>
+          </a:ln>
+        </p:spPr>
+        <p:style>
+          <a:lnRef idx="1">
+            <a:schemeClr val="accent1"/>
+          </a:lnRef>
+          <a:fillRef idx="3">
+            <a:schemeClr val="accent1"/>
+          </a:fillRef>
+          <a:effectRef idx="2">
+            <a:schemeClr val="accent1"/>
+          </a:effectRef>
+          <a:fontRef idx="minor">
+            <a:schemeClr val="lt1"/>
+          </a:fontRef>
+        </p:style>
+        <p:txBody>
+          <a:bodyPr rtlCol="0" anchor="ctr" wrap="square" lIns="36000" rIns="36000" tIns="21600" bIns="21600"/>
+          <a:lstStyle/>
+          <a:p>
+            <a:pPr algn="ctr"/>
+            <a:r>
+              <a:rPr sz="1250" b="1">
+                <a:solidFill>
+                  <a:srgbClr val="15181D"/>
+                </a:solidFill>
+                <a:latin typeface="맑은 고딕"/>
+              </a:rPr>
+              <a:t>Isaac 안 가상 M1013</a:t>
+            </a:r>
+          </a:p>
+        </p:txBody>
+      </p:sp>
+      <p:sp>
+        <p:nvSpPr>
+          <p:cNvPr id="12" name="TextBox 11"/>
+          <p:cNvSpPr txBox="1"/>
+          <p:nvPr/>
+        </p:nvSpPr>
+        <p:spPr>
+          <a:xfrm>
+            <a:off x="324000" y="2304000"/>
+            <a:ext cx="6480000" cy="432000"/>
+          </a:xfrm>
+          <a:prstGeom prst="rect">
+            <a:avLst/>
+          </a:prstGeom>
+          <a:noFill/>
+        </p:spPr>
+        <p:txBody>
+          <a:bodyPr wrap="square">
+            <a:spAutoFit/>
+          </a:bodyPr>
+          <a:lstStyle/>
+          <a:p>
+            <a:r>
+              <a:rPr sz="1300" b="1">
+                <a:solidFill>
+                  <a:srgbClr val="1F6B4A"/>
+                </a:solidFill>
+                <a:latin typeface="맑은 고딕"/>
+              </a:rPr>
+              <a:t>로봇 도착 후 (9/20~) — Isaac 은 루프에서 빠짐</a:t>
+            </a:r>
+          </a:p>
+        </p:txBody>
+      </p:sp>
+      <p:sp>
+        <p:nvSpPr>
+          <p:cNvPr id="13" name="Rounded Rectangle 12"/>
+          <p:cNvSpPr/>
+          <p:nvPr/>
+        </p:nvSpPr>
+        <p:spPr>
+          <a:xfrm>
+            <a:off x="324000" y="2592000"/>
+            <a:ext cx="2376000" cy="648000"/>
+          </a:xfrm>
+          <a:prstGeom prst="roundRect">
+            <a:avLst/>
+          </a:prstGeom>
+          <a:solidFill>
+            <a:srgbClr val="EDEFF3"/>
+          </a:solidFill>
+          <a:ln w="9525">
+            <a:solidFill>
+              <a:srgbClr val="C6CCD8"/>
+            </a:solidFill>
+          </a:ln>
+        </p:spPr>
+        <p:style>
+          <a:lnRef idx="1">
+            <a:schemeClr val="accent1"/>
+          </a:lnRef>
+          <a:fillRef idx="3">
+            <a:schemeClr val="accent1"/>
+          </a:fillRef>
+          <a:effectRef idx="2">
+            <a:schemeClr val="accent1"/>
+          </a:effectRef>
+          <a:fontRef idx="minor">
+            <a:schemeClr val="lt1"/>
+          </a:fontRef>
+        </p:style>
+        <p:txBody>
+          <a:bodyPr rtlCol="0" anchor="ctr" wrap="square" lIns="36000" rIns="36000" tIns="21600" bIns="21600"/>
+          <a:lstStyle/>
+          <a:p>
+            <a:pPr algn="ctr"/>
+            <a:r>
+              <a:rPr sz="1250" b="1">
+                <a:solidFill>
+                  <a:srgbClr val="15181D"/>
+                </a:solidFill>
+                <a:latin typeface="맑은 고딕"/>
+              </a:rPr>
+              <a:t>실물 카메라 사진</a:t>
+            </a:r>
+          </a:p>
+          <a:p>
+            <a:pPr algn="ctr"/>
+            <a:r>
+              <a:rPr sz="1050" b="0">
+                <a:solidFill>
+                  <a:srgbClr val="15181D"/>
+                </a:solidFill>
+                <a:latin typeface="맑은 고딕"/>
+              </a:rPr>
+              <a:t>+ 실물 관절 상태</a:t>
+            </a:r>
+          </a:p>
+        </p:txBody>
+      </p:sp>
+      <p:sp>
+        <p:nvSpPr>
+          <p:cNvPr id="14" name="Right Arrow 13"/>
+          <p:cNvSpPr/>
+          <p:nvPr/>
+        </p:nvSpPr>
+        <p:spPr>
+          <a:xfrm>
+            <a:off x="2736000" y="2826000"/>
+            <a:ext cx="251999" cy="180000"/>
+          </a:xfrm>
+          <a:prstGeom prst="rightArrow">
+            <a:avLst/>
+          </a:prstGeom>
+          <a:solidFill>
+            <a:srgbClr val="626B78"/>
+          </a:solidFill>
+          <a:ln>
+            <a:noFill/>
+          </a:ln>
+        </p:spPr>
+        <p:style>
+          <a:lnRef idx="1">
+            <a:schemeClr val="accent1"/>
+          </a:lnRef>
+          <a:fillRef idx="3">
+            <a:schemeClr val="accent1"/>
+          </a:fillRef>
+          <a:effectRef idx="2">
+            <a:schemeClr val="accent1"/>
+          </a:effectRef>
+          <a:fontRef idx="minor">
+            <a:schemeClr val="lt1"/>
+          </a:fontRef>
+        </p:style>
+        <p:txBody>
+          <a:bodyPr rtlCol="0" anchor="ctr"/>
+          <a:lstStyle/>
+          <a:p>
+            <a:pPr algn="ctr"/>
+          </a:p>
+        </p:txBody>
+      </p:sp>
+      <p:sp>
+        <p:nvSpPr>
+          <p:cNvPr id="15" name="Rounded Rectangle 14"/>
+          <p:cNvSpPr/>
+          <p:nvPr/>
+        </p:nvSpPr>
+        <p:spPr>
+          <a:xfrm>
+            <a:off x="3024000" y="2592000"/>
+            <a:ext cx="2376000" cy="648000"/>
+          </a:xfrm>
+          <a:prstGeom prst="roundRect">
+            <a:avLst/>
+          </a:prstGeom>
+          <a:solidFill>
+            <a:srgbClr val="2F3D9E"/>
+          </a:solidFill>
+          <a:ln w="9525">
+            <a:solidFill>
+              <a:srgbClr val="C6CCD8"/>
+            </a:solidFill>
+          </a:ln>
+        </p:spPr>
+        <p:style>
+          <a:lnRef idx="1">
+            <a:schemeClr val="accent1"/>
+          </a:lnRef>
+          <a:fillRef idx="3">
+            <a:schemeClr val="accent1"/>
+          </a:fillRef>
+          <a:effectRef idx="2">
+            <a:schemeClr val="accent1"/>
+          </a:effectRef>
+          <a:fontRef idx="minor">
+            <a:schemeClr val="lt1"/>
+          </a:fontRef>
+        </p:style>
+        <p:txBody>
+          <a:bodyPr rtlCol="0" anchor="ctr" wrap="square" lIns="36000" rIns="36000" tIns="21600" bIns="21600"/>
+          <a:lstStyle/>
+          <a:p>
+            <a:pPr algn="ctr"/>
+            <a:r>
+              <a:rPr sz="1250" b="1">
+                <a:solidFill>
+                  <a:srgbClr val="FFFFFF"/>
+                </a:solidFill>
+                <a:latin typeface="맑은 고딕"/>
+              </a:rPr>
+              <a:t>ACT 정책</a:t>
+            </a:r>
+          </a:p>
+        </p:txBody>
+      </p:sp>
+      <p:sp>
+        <p:nvSpPr>
+          <p:cNvPr id="16" name="Right Arrow 15"/>
+          <p:cNvSpPr/>
+          <p:nvPr/>
+        </p:nvSpPr>
+        <p:spPr>
+          <a:xfrm>
+            <a:off x="5436000" y="2826000"/>
+            <a:ext cx="251999" cy="180000"/>
+          </a:xfrm>
+          <a:prstGeom prst="rightArrow">
+            <a:avLst/>
+          </a:prstGeom>
+          <a:solidFill>
+            <a:srgbClr val="626B78"/>
+          </a:solidFill>
+          <a:ln>
+            <a:noFill/>
+          </a:ln>
+        </p:spPr>
+        <p:style>
+          <a:lnRef idx="1">
+            <a:schemeClr val="accent1"/>
+          </a:lnRef>
+          <a:fillRef idx="3">
+            <a:schemeClr val="accent1"/>
+          </a:fillRef>
+          <a:effectRef idx="2">
+            <a:schemeClr val="accent1"/>
+          </a:effectRef>
+          <a:fontRef idx="minor">
+            <a:schemeClr val="lt1"/>
+          </a:fontRef>
+        </p:style>
+        <p:txBody>
+          <a:bodyPr rtlCol="0" anchor="ctr"/>
+          <a:lstStyle/>
+          <a:p>
+            <a:pPr algn="ctr"/>
+          </a:p>
+        </p:txBody>
+      </p:sp>
+      <p:sp>
+        <p:nvSpPr>
+          <p:cNvPr id="17" name="Rounded Rectangle 16"/>
+          <p:cNvSpPr/>
+          <p:nvPr/>
+        </p:nvSpPr>
+        <p:spPr>
+          <a:xfrm>
+            <a:off x="5724000" y="2592000"/>
+            <a:ext cx="2376000" cy="648000"/>
+          </a:xfrm>
+          <a:prstGeom prst="roundRect">
+            <a:avLst/>
+          </a:prstGeom>
+          <a:solidFill>
+            <a:srgbClr val="EDEFF3"/>
+          </a:solidFill>
+          <a:ln w="9525">
+            <a:solidFill>
+              <a:srgbClr val="C6CCD8"/>
+            </a:solidFill>
+          </a:ln>
+        </p:spPr>
+        <p:style>
+          <a:lnRef idx="1">
+            <a:schemeClr val="accent1"/>
+          </a:lnRef>
+          <a:fillRef idx="3">
+            <a:schemeClr val="accent1"/>
+          </a:fillRef>
+          <a:effectRef idx="2">
+            <a:schemeClr val="accent1"/>
+          </a:effectRef>
+          <a:fontRef idx="minor">
+            <a:schemeClr val="lt1"/>
+          </a:fontRef>
+        </p:style>
+        <p:txBody>
+          <a:bodyPr rtlCol="0" anchor="ctr" wrap="square" lIns="36000" rIns="36000" tIns="21600" bIns="21600"/>
+          <a:lstStyle/>
+          <a:p>
+            <a:pPr algn="ctr"/>
+            <a:r>
+              <a:rPr sz="1250" b="1">
+                <a:solidFill>
+                  <a:srgbClr val="15181D"/>
+                </a:solidFill>
+                <a:latin typeface="맑은 고딕"/>
+              </a:rPr>
+              <a:t>관절 명령 (ROS2 dsr)</a:t>
+            </a:r>
+          </a:p>
+        </p:txBody>
+      </p:sp>
+      <p:sp>
+        <p:nvSpPr>
+          <p:cNvPr id="18" name="Right Arrow 17"/>
+          <p:cNvSpPr/>
+          <p:nvPr/>
+        </p:nvSpPr>
+        <p:spPr>
+          <a:xfrm>
+            <a:off x="8136000" y="2826000"/>
+            <a:ext cx="251999" cy="180000"/>
+          </a:xfrm>
+          <a:prstGeom prst="rightArrow">
+            <a:avLst/>
+          </a:prstGeom>
+          <a:solidFill>
+            <a:srgbClr val="626B78"/>
+          </a:solidFill>
+          <a:ln>
+            <a:noFill/>
+          </a:ln>
+        </p:spPr>
+        <p:style>
+          <a:lnRef idx="1">
+            <a:schemeClr val="accent1"/>
+          </a:lnRef>
+          <a:fillRef idx="3">
+            <a:schemeClr val="accent1"/>
+          </a:fillRef>
+          <a:effectRef idx="2">
+            <a:schemeClr val="accent1"/>
+          </a:effectRef>
+          <a:fontRef idx="minor">
+            <a:schemeClr val="lt1"/>
+          </a:fontRef>
+        </p:style>
+        <p:txBody>
+          <a:bodyPr rtlCol="0" anchor="ctr"/>
+          <a:lstStyle/>
+          <a:p>
+            <a:pPr algn="ctr"/>
+          </a:p>
+        </p:txBody>
+      </p:sp>
+      <p:sp>
+        <p:nvSpPr>
+          <p:cNvPr id="19" name="Rounded Rectangle 18"/>
+          <p:cNvSpPr/>
+          <p:nvPr/>
+        </p:nvSpPr>
+        <p:spPr>
+          <a:xfrm>
+            <a:off x="8424000" y="2592000"/>
+            <a:ext cx="2376000" cy="648000"/>
+          </a:xfrm>
+          <a:prstGeom prst="roundRect">
+            <a:avLst/>
+          </a:prstGeom>
+          <a:solidFill>
+            <a:srgbClr val="1F6B4A"/>
+          </a:solidFill>
+          <a:ln w="9525">
+            <a:solidFill>
+              <a:srgbClr val="C6CCD8"/>
+            </a:solidFill>
+          </a:ln>
+        </p:spPr>
+        <p:style>
+          <a:lnRef idx="1">
+            <a:schemeClr val="accent1"/>
+          </a:lnRef>
+          <a:fillRef idx="3">
+            <a:schemeClr val="accent1"/>
+          </a:fillRef>
+          <a:effectRef idx="2">
+            <a:schemeClr val="accent1"/>
+          </a:effectRef>
+          <a:fontRef idx="minor">
+            <a:schemeClr val="lt1"/>
+          </a:fontRef>
+        </p:style>
+        <p:txBody>
+          <a:bodyPr rtlCol="0" anchor="ctr" wrap="square" lIns="36000" rIns="36000" tIns="21600" bIns="21600"/>
+          <a:lstStyle/>
+          <a:p>
+            <a:pPr algn="ctr"/>
+            <a:r>
+              <a:rPr sz="1250" b="1">
+                <a:solidFill>
+                  <a:srgbClr val="FFFFFF"/>
+                </a:solidFill>
+                <a:latin typeface="맑은 고딕"/>
+              </a:rPr>
+              <a:t>진짜 M1013</a:t>
+            </a:r>
+          </a:p>
+        </p:txBody>
+      </p:sp>
+      <p:sp>
+        <p:nvSpPr>
+          <p:cNvPr id="20" name="TextBox 19"/>
+          <p:cNvSpPr txBox="1"/>
+          <p:nvPr/>
+        </p:nvSpPr>
+        <p:spPr>
+          <a:xfrm>
+            <a:off x="324000" y="3420000"/>
+            <a:ext cx="11520000" cy="2880000"/>
+          </a:xfrm>
+          <a:prstGeom prst="rect">
+            <a:avLst/>
+          </a:prstGeom>
+          <a:noFill/>
+        </p:spPr>
+        <p:txBody>
+          <a:bodyPr wrap="square">
+            <a:spAutoFit/>
+          </a:bodyPr>
+          <a:lstStyle/>
+          <a:p>
+            <a:pPr>
+              <a:spcAft>
+                <a:spcPts val="600"/>
+              </a:spcAft>
+            </a:pPr>
+            <a:r>
+              <a:rPr sz="1450" b="1">
+                <a:solidFill>
+                  <a:srgbClr val="15181D"/>
+                </a:solidFill>
+                <a:latin typeface="맑은 고딕"/>
+              </a:rPr>
+              <a:t>▪  가상 카메라가 실물 카메라로 '변신'하는 것이 아님 — 같은 자리에 번갈아 꽂히는 서로 다른 두 장치</a:t>
+            </a:r>
+          </a:p>
+          <a:p>
+            <a:pPr>
+              <a:spcAft>
+                <a:spcPts val="600"/>
+              </a:spcAft>
+            </a:pPr>
+            <a:r>
+              <a:rPr sz="1400" b="1">
+                <a:solidFill>
+                  <a:srgbClr val="15181D"/>
+                </a:solidFill>
+                <a:latin typeface="맑은 고딕"/>
+              </a:rPr>
+              <a:t>▪  오늘 값의 두 가지 쓰임:</a:t>
+            </a:r>
+          </a:p>
+          <a:p>
+            <a:pPr lvl="1">
+              <a:spcAft>
+                <a:spcPts val="600"/>
+              </a:spcAft>
+            </a:pPr>
+            <a:r>
+              <a:rPr sz="1300" b="1">
+                <a:solidFill>
+                  <a:srgbClr val="15181D"/>
+                </a:solidFill>
+                <a:latin typeface="맑은 고딕"/>
+              </a:rPr>
+              <a:t>–  ㉠ 실물 마운트 설계의 출발점 — 단, 그대로 복사는 불가</a:t>
+            </a:r>
+          </a:p>
+          <a:p>
+            <a:pPr lvl="2">
+              <a:spcAft>
+                <a:spcPts val="600"/>
+              </a:spcAft>
+            </a:pPr>
+            <a:r>
+              <a:rPr sz="1250" b="0">
+                <a:solidFill>
+                  <a:srgbClr val="15181D"/>
+                </a:solidFill>
+                <a:latin typeface="맑은 고딕"/>
+              </a:rPr>
+              <a:t>·  FOV 는 마운트가 아니라 카메라 부품이 결정 (오늘 60°는 절충값) → 부품 확정 후 위치 재계산</a:t>
+            </a:r>
+          </a:p>
+          <a:p>
+            <a:pPr lvl="2">
+              <a:spcAft>
+                <a:spcPts val="600"/>
+              </a:spcAft>
+            </a:pPr>
+            <a:r>
+              <a:rPr sz="1250" b="0">
+                <a:solidFill>
+                  <a:srgbClr val="15181D"/>
+                </a:solidFill>
+                <a:latin typeface="맑은 고딕"/>
+              </a:rPr>
+              <a:t>·  기구 제약 우선 — LEHR 본체·케이블 회피, 파지 시 테이블 충돌 없어야</a:t>
+            </a:r>
+          </a:p>
+          <a:p>
+            <a:pPr lvl="2">
+              <a:spcAft>
+                <a:spcPts val="600"/>
+              </a:spcAft>
+            </a:pPr>
+            <a:r>
+              <a:rPr sz="1250" b="0">
+                <a:solidFill>
+                  <a:srgbClr val="15181D"/>
+                </a:solidFill>
+                <a:latin typeface="맑은 고딕"/>
+              </a:rPr>
+              <a:t>·  OMX 화면의 완전 재현은 애초 불가 (M1013 그리퍼가 길어 실물 대비 약 70% 크기)</a:t>
+            </a:r>
+          </a:p>
+          <a:p>
+            <a:pPr lvl="1">
+              <a:spcAft>
+                <a:spcPts val="600"/>
+              </a:spcAft>
+            </a:pPr>
+            <a:r>
+              <a:rPr sz="1300" b="1">
+                <a:solidFill>
+                  <a:srgbClr val="15181D"/>
+                </a:solidFill>
+                <a:latin typeface="맑은 고딕"/>
+              </a:rPr>
+              <a:t>–  ㉡ 설치 후 실측값으로 sim 갱신 → 이후에도 실물 대신 위험한 시도를 먼저 해보는 연습장으로 유지</a:t>
+            </a:r>
+          </a:p>
+          <a:p>
+            <a:pPr>
+              <a:spcAft>
+                <a:spcPts val="600"/>
+              </a:spcAft>
+            </a:pPr>
+            <a:r>
+              <a:rPr sz="1350" b="1">
+                <a:solidFill>
+                  <a:srgbClr val="1F6B4A"/>
+                </a:solidFill>
+                <a:latin typeface="맑은 고딕"/>
+              </a:rPr>
+              <a:t>▪  권장 순서:  카메라 부품 결정 → 기구적으로 가능한 마운트 설계 → sim 에서 시야 검증(프린팅 전) → 설치 후 실측 → JSON 갱신</a:t>
+            </a:r>
+          </a:p>
+        </p:txBody>
+      </p:sp>
+      <p:sp>
+        <p:nvSpPr>
+          <p:cNvPr id="21" name="TextBox 20"/>
+          <p:cNvSpPr txBox="1"/>
+          <p:nvPr/>
+        </p:nvSpPr>
+        <p:spPr>
+          <a:xfrm>
+            <a:off x="324000" y="6598800"/>
+            <a:ext cx="11544119" cy="216000"/>
+          </a:xfrm>
+          <a:prstGeom prst="rect">
+            <a:avLst/>
+          </a:prstGeom>
+          <a:noFill/>
+        </p:spPr>
+        <p:txBody>
+          <a:bodyPr wrap="square">
+            <a:spAutoFit/>
+          </a:bodyPr>
+          <a:lstStyle/>
+          <a:p>
+            <a:r>
+              <a:rPr sz="1000" b="0">
+                <a:solidFill>
+                  <a:srgbClr val="626B78"/>
+                </a:solidFill>
+                <a:latin typeface="맑은 고딕"/>
+              </a:rPr>
+              <a:t>M1013 전이 · STEP 5 카메라 정합 · 2026-08-24</a:t>
+            </a:r>
+          </a:p>
+        </p:txBody>
+      </p:sp>
+    </p:spTree>
+  </p:cSld>
+  <p:clrMapOvr>
+    <a:masterClrMapping/>
+  </p:clrMapOvr>
+</p:sld>
+</file>
+
+<file path=ppt/slides/slide15.xml><?xml version="1.0" encoding="utf-8"?>
+<p:sld xmlns:a="http://schemas.openxmlformats.org/drawingml/2006/main" xmlns:p="http://schemas.openxmlformats.org/presentationml/2006/main" xmlns:r="http://schemas.openxmlformats.org/officeDocument/2006/relationships">
+  <p:cSld>
+    <p:spTree>
+      <p:nvGrpSpPr>
+        <p:cNvPr id="1" name=""/>
+        <p:cNvGrpSpPr/>
+        <p:nvPr/>
+      </p:nvGrpSpPr>
+      <p:grpSpPr/>
+      <p:sp>
+        <p:nvSpPr>
+          <p:cNvPr id="2" name="Rectangle 1"/>
+          <p:cNvSpPr/>
+          <p:nvPr/>
+        </p:nvSpPr>
+        <p:spPr>
+          <a:xfrm>
+            <a:off x="0" y="0"/>
+            <a:ext cx="12192119" cy="720000"/>
+          </a:xfrm>
+          <a:prstGeom prst="rect">
+            <a:avLst/>
+          </a:prstGeom>
+          <a:solidFill>
+            <a:srgbClr val="2F3D9E"/>
+          </a:solidFill>
+          <a:ln>
+            <a:noFill/>
+          </a:ln>
+        </p:spPr>
+        <p:style>
+          <a:lnRef idx="1">
+            <a:schemeClr val="accent1"/>
+          </a:lnRef>
+          <a:fillRef idx="3">
+            <a:schemeClr val="accent1"/>
+          </a:fillRef>
+          <a:effectRef idx="2">
+            <a:schemeClr val="accent1"/>
+          </a:effectRef>
+          <a:fontRef idx="minor">
+            <a:schemeClr val="lt1"/>
+          </a:fontRef>
+        </p:style>
+        <p:txBody>
+          <a:bodyPr rtlCol="0" anchor="ctr" lIns="324000" tIns="93600"/>
+          <a:lstStyle/>
+          <a:p>
+            <a:pPr algn="ctr"/>
+            <a:r>
+              <a:rPr sz="1500" b="1">
+                <a:solidFill>
+                  <a:srgbClr val="B9C2F0"/>
+                </a:solidFill>
+                <a:latin typeface="맑은 고딕"/>
+              </a:rPr>
+              <a:t>10 재평가  </a:t>
+            </a:r>
+            <a:r>
+              <a:rPr sz="2100" b="1">
+                <a:solidFill>
+                  <a:srgbClr val="FFFFFF"/>
+                </a:solidFill>
+                <a:latin typeface="맑은 고딕"/>
+              </a:rPr>
+              <a:t>방법 재평가 — 다시 정밀도가 필요해지면 이 경로로</a:t>
+            </a:r>
+          </a:p>
+        </p:txBody>
+      </p:sp>
+      <p:sp>
+        <p:nvSpPr>
+          <p:cNvPr id="3" name="TextBox 2"/>
+          <p:cNvSpPr txBox="1"/>
+          <p:nvPr/>
+        </p:nvSpPr>
+        <p:spPr>
+          <a:xfrm>
+            <a:off x="324000" y="864000"/>
+            <a:ext cx="11520000" cy="503999"/>
+          </a:xfrm>
+          <a:prstGeom prst="rect">
+            <a:avLst/>
+          </a:prstGeom>
+          <a:noFill/>
+        </p:spPr>
+        <p:txBody>
+          <a:bodyPr wrap="square">
+            <a:spAutoFit/>
+          </a:bodyPr>
+          <a:lstStyle/>
+          <a:p>
+            <a:pPr>
+              <a:spcAft>
+                <a:spcPts val="600"/>
+              </a:spcAft>
+            </a:pPr>
+            <a:r>
+              <a:rPr sz="1400" b="1">
+                <a:solidFill>
+                  <a:srgbClr val="15181D"/>
+                </a:solidFill>
+                <a:latin typeface="맑은 고딕"/>
+              </a:rPr>
+              <a:t>▪  오늘 방식(겉보기 정합)은 상황상 합리적이었으나 교과서적 방법은 아니었음 — 아래는 검토 후 확인한 더 나은 접근</a:t>
+            </a:r>
+          </a:p>
+        </p:txBody>
+      </p:sp>
+      <p:graphicFrame>
+        <p:nvGraphicFramePr>
+          <p:cNvPr id="4" name="Table 3"/>
+          <p:cNvGraphicFramePr>
+            <a:graphicFrameLocks noGrp="1"/>
+          </p:cNvGraphicFramePr>
+          <p:nvPr/>
+        </p:nvGraphicFramePr>
+        <p:xfrm>
+          <a:off x="324000" y="1440000"/>
+          <a:ext cx="11555998" cy="4104000"/>
+        </p:xfrm>
+        <a:graphic>
+          <a:graphicData uri="http://schemas.openxmlformats.org/drawingml/2006/table">
+            <a:tbl>
+              <a:tblPr firstRow="1" bandRow="1">
+                <a:tableStyleId>{5C22544A-7EE6-4342-B048-85BDC9FD1C3A}</a:tableStyleId>
+              </a:tblPr>
+              <a:tblGrid>
+                <a:gridCol w="1890981"/>
+                <a:gridCol w="4412290"/>
+                <a:gridCol w="5252727"/>
+              </a:tblGrid>
+              <a:tr h="684000">
+                <a:tc>
+                  <a:txBody>
+                    <a:bodyPr/>
+                    <a:lstStyle/>
+                    <a:p>
+                      <a:r>
+                        <a:rPr sz="1150" b="1">
+                          <a:solidFill>
+                            <a:srgbClr val="FFFFFF"/>
+                          </a:solidFill>
+                          <a:latin typeface="맑은 고딕"/>
+                        </a:rPr>
+                        <a:t>방법</a:t>
+                      </a:r>
+                    </a:p>
+                  </a:txBody>
+                  <a:tcPr marL="57600" marR="57600" marT="18000" marB="18000" anchor="ctr">
+                    <a:solidFill>
+                      <a:srgbClr val="2F3D9E"/>
+                    </a:solidFill>
+                  </a:tcPr>
+                </a:tc>
+                <a:tc>
+                  <a:txBody>
+                    <a:bodyPr/>
+                    <a:lstStyle/>
+                    <a:p>
+                      <a:r>
+                        <a:rPr sz="1150" b="1">
+                          <a:solidFill>
+                            <a:srgbClr val="FFFFFF"/>
+                          </a:solidFill>
+                          <a:latin typeface="맑은 고딕"/>
+                        </a:rPr>
+                        <a:t>내용</a:t>
+                      </a:r>
+                    </a:p>
+                  </a:txBody>
+                  <a:tcPr marL="57600" marR="57600" marT="18000" marB="18000" anchor="ctr">
+                    <a:solidFill>
+                      <a:srgbClr val="2F3D9E"/>
+                    </a:solidFill>
+                  </a:tcPr>
+                </a:tc>
+                <a:tc>
+                  <a:txBody>
+                    <a:bodyPr/>
+                    <a:lstStyle/>
+                    <a:p>
+                      <a:r>
+                        <a:rPr sz="1150" b="1">
+                          <a:solidFill>
+                            <a:srgbClr val="FFFFFF"/>
+                          </a:solidFill>
+                          <a:latin typeface="맑은 고딕"/>
+                        </a:rPr>
+                        <a:t>평가</a:t>
+                      </a:r>
+                    </a:p>
+                  </a:txBody>
+                  <a:tcPr marL="57600" marR="57600" marT="18000" marB="18000" anchor="ctr">
+                    <a:solidFill>
+                      <a:srgbClr val="2F3D9E"/>
+                    </a:solidFill>
+                  </a:tcPr>
+                </a:tc>
+              </a:tr>
+              <a:tr h="684000">
+                <a:tc>
+                  <a:txBody>
+                    <a:bodyPr/>
+                    <a:lstStyle/>
+                    <a:p>
+                      <a:r>
+                        <a:rPr sz="1150" b="0">
+                          <a:solidFill>
+                            <a:srgbClr val="15181D"/>
+                          </a:solidFill>
+                          <a:latin typeface="맑은 고딕"/>
+                        </a:rPr>
+                        <a:t>실물 리그 실측</a:t>
+                      </a:r>
+                    </a:p>
+                  </a:txBody>
+                  <a:tcPr marL="57600" marR="57600" marT="18000" marB="18000" anchor="ctr">
+                    <a:solidFill>
+                      <a:srgbClr val="FFFFFF"/>
+                    </a:solidFill>
+                  </a:tcPr>
+                </a:tc>
+                <a:tc>
+                  <a:txBody>
+                    <a:bodyPr/>
+                    <a:lstStyle/>
+                    <a:p>
+                      <a:r>
+                        <a:rPr sz="1150" b="0">
+                          <a:solidFill>
+                            <a:srgbClr val="15181D"/>
+                          </a:solidFill>
+                          <a:latin typeface="맑은 고딕"/>
+                        </a:rPr>
+                        <a:t>OMX 정면캠 위치를 베이스 기준으로 자로 재고, 웹캠 모델명으로 FOV 스펙 확인</a:t>
+                      </a:r>
+                    </a:p>
+                  </a:txBody>
+                  <a:tcPr marL="57600" marR="57600" marT="18000" marB="18000" anchor="ctr">
+                    <a:solidFill>
+                      <a:srgbClr val="FFFFFF"/>
+                    </a:solidFill>
+                  </a:tcPr>
+                </a:tc>
+                <a:tc>
+                  <a:txBody>
+                    <a:bodyPr/>
+                    <a:lstStyle/>
+                    <a:p>
+                      <a:r>
+                        <a:rPr sz="1150" b="1">
+                          <a:solidFill>
+                            <a:srgbClr val="A9331D"/>
+                          </a:solidFill>
+                          <a:latin typeface="맑은 고딕"/>
+                        </a:rPr>
+                        <a:t>가장 싸고 확실 — 3라운드 탐색을 5분에 대체 가능했음 (미제안은 실수)</a:t>
+                      </a:r>
+                    </a:p>
+                  </a:txBody>
+                  <a:tcPr marL="57600" marR="57600" marT="18000" marB="18000" anchor="ctr">
+                    <a:solidFill>
+                      <a:srgbClr val="FFFFFF"/>
+                    </a:solidFill>
+                  </a:tcPr>
+                </a:tc>
+              </a:tr>
+              <a:tr h="684000">
+                <a:tc>
+                  <a:txBody>
+                    <a:bodyPr/>
+                    <a:lstStyle/>
+                    <a:p>
+                      <a:r>
+                        <a:rPr sz="1150" b="0">
+                          <a:solidFill>
+                            <a:srgbClr val="15181D"/>
+                          </a:solidFill>
+                          <a:latin typeface="맑은 고딕"/>
+                        </a:rPr>
+                        <a:t>정면캠 solvePnP</a:t>
+                      </a:r>
+                    </a:p>
+                  </a:txBody>
+                  <a:tcPr marL="57600" marR="57600" marT="18000" marB="18000" anchor="ctr">
+                    <a:solidFill>
+                      <a:srgbClr val="EDEFF3"/>
+                    </a:solidFill>
+                  </a:tcPr>
+                </a:tc>
+                <a:tc>
+                  <a:txBody>
+                    <a:bodyPr/>
+                    <a:lstStyle/>
+                    <a:p>
+                      <a:r>
+                        <a:rPr sz="1150" b="0">
+                          <a:solidFill>
+                            <a:srgbClr val="15181D"/>
+                          </a:solidFill>
+                          <a:latin typeface="맑은 고딕"/>
+                        </a:rPr>
+                        <a:t>에피소드별 큐브 파지 위치(3D, 그리퍼 닫힘 시점 EE) ↔ 영상 속 큐브 픽셀(2D) 159쌍으로 포즈 복원</a:t>
+                      </a:r>
+                    </a:p>
+                  </a:txBody>
+                  <a:tcPr marL="57600" marR="57600" marT="18000" marB="18000" anchor="ctr">
+                    <a:solidFill>
+                      <a:srgbClr val="EDEFF3"/>
+                    </a:solidFill>
+                  </a:tcPr>
+                </a:tc>
+                <a:tc>
+                  <a:txBody>
+                    <a:bodyPr/>
+                    <a:lstStyle/>
+                    <a:p>
+                      <a:r>
+                        <a:rPr sz="1150" b="1">
+                          <a:solidFill>
+                            <a:srgbClr val="15181D"/>
+                          </a:solidFill>
+                          <a:latin typeface="맑은 고딕"/>
+                        </a:rPr>
+                        <a:t>★ 타깃이 없던 게 아니라 큐브가 곧 타깃이었음. 비스듬한 시선이라 초점거리 추정 조건도 양호</a:t>
+                      </a:r>
+                    </a:p>
+                  </a:txBody>
+                  <a:tcPr marL="57600" marR="57600" marT="18000" marB="18000" anchor="ctr">
+                    <a:solidFill>
+                      <a:srgbClr val="EDEFF3"/>
+                    </a:solidFill>
+                  </a:tcPr>
+                </a:tc>
+              </a:tr>
+              <a:tr h="684000">
+                <a:tc>
+                  <a:txBody>
+                    <a:bodyPr/>
+                    <a:lstStyle/>
+                    <a:p>
+                      <a:r>
+                        <a:rPr sz="1150" b="0">
+                          <a:solidFill>
+                            <a:srgbClr val="15181D"/>
+                          </a:solidFill>
+                          <a:latin typeface="맑은 고딕"/>
+                        </a:rPr>
+                        <a:t>손목캠 hand-eye</a:t>
+                      </a:r>
+                    </a:p>
+                  </a:txBody>
+                  <a:tcPr marL="57600" marR="57600" marT="18000" marB="18000" anchor="ctr">
+                    <a:solidFill>
+                      <a:srgbClr val="FFFFFF"/>
+                    </a:solidFill>
+                  </a:tcPr>
+                </a:tc>
+                <a:tc>
+                  <a:txBody>
+                    <a:bodyPr/>
+                    <a:lstStyle/>
+                    <a:p>
+                      <a:r>
+                        <a:rPr sz="1150" b="0">
+                          <a:solidFill>
+                            <a:srgbClr val="15181D"/>
+                          </a:solidFill>
+                          <a:latin typeface="맑은 고딕"/>
+                        </a:rPr>
+                        <a:t>FK 플랜지 포즈 + 큐브 관측의 재투영 오차 최소화로 '플랜지→카메라' 변환 유도</a:t>
+                      </a:r>
+                    </a:p>
+                  </a:txBody>
+                  <a:tcPr marL="57600" marR="57600" marT="18000" marB="18000" anchor="ctr">
+                    <a:solidFill>
+                      <a:srgbClr val="FFFFFF"/>
+                    </a:solidFill>
+                  </a:tcPr>
+                </a:tc>
+                <a:tc>
+                  <a:txBody>
+                    <a:bodyPr/>
+                    <a:lstStyle/>
+                    <a:p>
+                      <a:r>
+                        <a:rPr sz="1150" b="1">
+                          <a:solidFill>
+                            <a:srgbClr val="15181D"/>
+                          </a:solidFill>
+                          <a:latin typeface="맑은 고딕"/>
+                        </a:rPr>
+                        <a:t>표준 알고리즘(cv2.calibrateHandEye 계열). 이 방식이면 +55° 경험적 보정 자체가 불필요</a:t>
+                      </a:r>
+                    </a:p>
+                  </a:txBody>
+                  <a:tcPr marL="57600" marR="57600" marT="18000" marB="18000" anchor="ctr">
+                    <a:solidFill>
+                      <a:srgbClr val="FFFFFF"/>
+                    </a:solidFill>
+                  </a:tcPr>
+                </a:tc>
+              </a:tr>
+              <a:tr h="684000">
+                <a:tc>
+                  <a:txBody>
+                    <a:bodyPr/>
+                    <a:lstStyle/>
+                    <a:p>
+                      <a:r>
+                        <a:rPr sz="1150" b="0">
+                          <a:solidFill>
+                            <a:srgbClr val="15181D"/>
+                          </a:solidFill>
+                          <a:latin typeface="맑은 고딕"/>
+                        </a:rPr>
+                        <a:t>정책 액션 오차 지표</a:t>
+                      </a:r>
+                    </a:p>
+                  </a:txBody>
+                  <a:tcPr marL="57600" marR="57600" marT="18000" marB="18000" anchor="ctr">
+                    <a:solidFill>
+                      <a:srgbClr val="EDEFF3"/>
+                    </a:solidFill>
+                  </a:tcPr>
+                </a:tc>
+                <a:tc>
+                  <a:txBody>
+                    <a:bodyPr/>
+                    <a:lstStyle/>
+                    <a:p>
+                      <a:r>
+                        <a:rPr sz="1150" b="0">
+                          <a:solidFill>
+                            <a:srgbClr val="15181D"/>
+                          </a:solidFill>
+                          <a:latin typeface="맑은 고딕"/>
+                        </a:rPr>
+                        <a:t>GT 궤적 재생 → 렌더 관측을 정책에 투입 → 실제 영상 투입 시 예측과 비교</a:t>
+                      </a:r>
+                    </a:p>
+                  </a:txBody>
+                  <a:tcPr marL="57600" marR="57600" marT="18000" marB="18000" anchor="ctr">
+                    <a:solidFill>
+                      <a:srgbClr val="EDEFF3"/>
+                    </a:solidFill>
+                  </a:tcPr>
+                </a:tc>
+                <a:tc>
+                  <a:txBody>
+                    <a:bodyPr/>
+                    <a:lstStyle/>
+                    <a:p>
+                      <a:r>
+                        <a:rPr sz="1150" b="0">
+                          <a:solidFill>
+                            <a:srgbClr val="15181D"/>
+                          </a:solidFill>
+                          <a:latin typeface="맑은 고딕"/>
+                        </a:rPr>
+                        <a:t>픽셀 눈대중 대신 '목적에 직접 맞는' 채점. 제어 루프 없이 반나절 — 다만 실물 갭 예측력은 낮음</a:t>
+                      </a:r>
+                    </a:p>
+                  </a:txBody>
+                  <a:tcPr marL="57600" marR="57600" marT="18000" marB="18000" anchor="ctr">
+                    <a:solidFill>
+                      <a:srgbClr val="EDEFF3"/>
+                    </a:solidFill>
+                  </a:tcPr>
+                </a:tc>
+              </a:tr>
+              <a:tr h="684000">
+                <a:tc>
+                  <a:txBody>
+                    <a:bodyPr/>
+                    <a:lstStyle/>
+                    <a:p>
+                      <a:r>
+                        <a:rPr sz="1150" b="0">
+                          <a:solidFill>
+                            <a:srgbClr val="15181D"/>
+                          </a:solidFill>
+                          <a:latin typeface="맑은 고딕"/>
+                        </a:rPr>
+                        <a:t>카메라 포즈 랜덤화</a:t>
+                      </a:r>
+                    </a:p>
+                  </a:txBody>
+                  <a:tcPr marL="57600" marR="57600" marT="18000" marB="18000" anchor="ctr">
+                    <a:solidFill>
+                      <a:srgbClr val="FFFFFF"/>
+                    </a:solidFill>
+                  </a:tcPr>
+                </a:tc>
+                <a:tc>
+                  <a:txBody>
+                    <a:bodyPr/>
+                    <a:lstStyle/>
+                    <a:p>
+                      <a:r>
+                        <a:rPr sz="1150" b="0">
+                          <a:solidFill>
+                            <a:srgbClr val="15181D"/>
+                          </a:solidFill>
+                          <a:latin typeface="맑은 고딕"/>
+                        </a:rPr>
+                        <a:t>재렌더 시 카메라 포즈를 ±범위로 흔들어 학습</a:t>
+                      </a:r>
+                    </a:p>
+                  </a:txBody>
+                  <a:tcPr marL="57600" marR="57600" marT="18000" marB="18000" anchor="ctr">
+                    <a:solidFill>
+                      <a:srgbClr val="FFFFFF"/>
+                    </a:solidFill>
+                  </a:tcPr>
+                </a:tc>
+                <a:tc>
+                  <a:txBody>
+                    <a:bodyPr/>
+                    <a:lstStyle/>
+                    <a:p>
+                      <a:r>
+                        <a:rPr sz="1150" b="0">
+                          <a:solidFill>
+                            <a:srgbClr val="15181D"/>
+                          </a:solidFill>
+                          <a:latin typeface="맑은 고딕"/>
+                        </a:rPr>
+                        <a:t>sim2real 표준 관행 — 잔여 오정합에 정책이 둔감해짐 (co-training 채택 시 함께 적용)</a:t>
+                      </a:r>
+                    </a:p>
+                  </a:txBody>
+                  <a:tcPr marL="57600" marR="57600" marT="18000" marB="18000" anchor="ctr">
+                    <a:solidFill>
+                      <a:srgbClr val="FFFFFF"/>
+                    </a:solidFill>
+                  </a:tcPr>
+                </a:tc>
+              </a:tr>
+            </a:tbl>
+          </a:graphicData>
+        </a:graphic>
+      </p:graphicFrame>
+      <p:sp>
+        <p:nvSpPr>
+          <p:cNvPr id="5" name="TextBox 4"/>
+          <p:cNvSpPr txBox="1"/>
+          <p:nvPr/>
+        </p:nvSpPr>
+        <p:spPr>
+          <a:xfrm>
+            <a:off x="324000" y="5616000"/>
+            <a:ext cx="11520000" cy="864000"/>
+          </a:xfrm>
+          <a:prstGeom prst="rect">
+            <a:avLst/>
+          </a:prstGeom>
+          <a:noFill/>
+        </p:spPr>
+        <p:txBody>
+          <a:bodyPr wrap="square">
+            <a:spAutoFit/>
+          </a:bodyPr>
+          <a:lstStyle/>
+          <a:p>
+            <a:pPr>
+              <a:spcAft>
+                <a:spcPts val="600"/>
+              </a:spcAft>
+            </a:pPr>
+            <a:r>
+              <a:rPr sz="1300" b="1">
+                <a:solidFill>
+                  <a:srgbClr val="A9331D"/>
+                </a:solidFill>
+                <a:latin typeface="맑은 고딕"/>
+              </a:rPr>
+              <a:t>▪  정정 사항: 6장에서 PnP 를 '캘리브레이션 타깃 없음'으로 기각했으나 오판 — 데이터셋에 이미 159쌍의 3D↔2D 대응이 존재했음</a:t>
+            </a:r>
+          </a:p>
+          <a:p>
+            <a:pPr>
+              <a:spcAft>
+                <a:spcPts val="600"/>
+              </a:spcAft>
+            </a:pPr>
+            <a:r>
+              <a:rPr sz="1300" b="0">
+                <a:solidFill>
+                  <a:srgbClr val="15181D"/>
+                </a:solidFill>
+                <a:latin typeface="맑은 고딕"/>
+              </a:rPr>
+              <a:t>▪  단, 이 정밀 경로는 v7 이어학습 여부에 따라 필요성이 달라짐 (다음 장) — 실물 마운트 설계 시점에 재검토</a:t>
+            </a:r>
+          </a:p>
+        </p:txBody>
+      </p:sp>
+      <p:sp>
+        <p:nvSpPr>
+          <p:cNvPr id="6" name="TextBox 5"/>
+          <p:cNvSpPr txBox="1"/>
+          <p:nvPr/>
+        </p:nvSpPr>
+        <p:spPr>
+          <a:xfrm>
+            <a:off x="324000" y="6598800"/>
+            <a:ext cx="11544119" cy="216000"/>
+          </a:xfrm>
+          <a:prstGeom prst="rect">
+            <a:avLst/>
+          </a:prstGeom>
+          <a:noFill/>
+        </p:spPr>
+        <p:txBody>
+          <a:bodyPr wrap="square">
+            <a:spAutoFit/>
+          </a:bodyPr>
+          <a:lstStyle/>
+          <a:p>
+            <a:r>
+              <a:rPr sz="1000" b="0">
+                <a:solidFill>
+                  <a:srgbClr val="626B78"/>
+                </a:solidFill>
+                <a:latin typeface="맑은 고딕"/>
+              </a:rPr>
+              <a:t>M1013 전이 · STEP 5 카메라 정합 · 2026-08-24</a:t>
+            </a:r>
+          </a:p>
+        </p:txBody>
+      </p:sp>
+    </p:spTree>
+  </p:cSld>
+  <p:clrMapOvr>
+    <a:masterClrMapping/>
+  </p:clrMapOvr>
+</p:sld>
+</file>
+
+<file path=ppt/slides/slide16.xml><?xml version="1.0" encoding="utf-8"?>
+<p:sld xmlns:a="http://schemas.openxmlformats.org/drawingml/2006/main" xmlns:p="http://schemas.openxmlformats.org/presentationml/2006/main" xmlns:r="http://schemas.openxmlformats.org/officeDocument/2006/relationships">
+  <p:cSld>
+    <p:spTree>
+      <p:nvGrpSpPr>
+        <p:cNvPr id="1" name=""/>
+        <p:cNvGrpSpPr/>
+        <p:nvPr/>
+      </p:nvGrpSpPr>
+      <p:grpSpPr/>
+      <p:sp>
+        <p:nvSpPr>
+          <p:cNvPr id="2" name="Rectangle 1"/>
+          <p:cNvSpPr/>
+          <p:nvPr/>
+        </p:nvSpPr>
+        <p:spPr>
+          <a:xfrm>
+            <a:off x="0" y="0"/>
+            <a:ext cx="12192119" cy="720000"/>
+          </a:xfrm>
+          <a:prstGeom prst="rect">
+            <a:avLst/>
+          </a:prstGeom>
+          <a:solidFill>
+            <a:srgbClr val="2F3D9E"/>
+          </a:solidFill>
+          <a:ln>
+            <a:noFill/>
+          </a:ln>
+        </p:spPr>
+        <p:style>
+          <a:lnRef idx="1">
+            <a:schemeClr val="accent1"/>
+          </a:lnRef>
+          <a:fillRef idx="3">
+            <a:schemeClr val="accent1"/>
+          </a:fillRef>
+          <a:effectRef idx="2">
+            <a:schemeClr val="accent1"/>
+          </a:effectRef>
+          <a:fontRef idx="minor">
+            <a:schemeClr val="lt1"/>
+          </a:fontRef>
+        </p:style>
+        <p:txBody>
+          <a:bodyPr rtlCol="0" anchor="ctr" lIns="324000" tIns="93600"/>
+          <a:lstStyle/>
+          <a:p>
+            <a:pPr algn="ctr"/>
+            <a:r>
+              <a:rPr sz="1500" b="1">
+                <a:solidFill>
+                  <a:srgbClr val="B9C2F0"/>
+                </a:solidFill>
+                <a:latin typeface="맑은 고딕"/>
+              </a:rPr>
+              <a:t>11 계획  </a:t>
+            </a:r>
+            <a:r>
+              <a:rPr sz="2100" b="1">
+                <a:solidFill>
+                  <a:srgbClr val="FFFFFF"/>
+                </a:solidFill>
+                <a:latin typeface="맑은 고딕"/>
+              </a:rPr>
+              <a:t>범위 조정과 4주 준비 계획 — 실물 도착 2026-09-20</a:t>
+            </a:r>
+          </a:p>
+        </p:txBody>
+      </p:sp>
+      <p:sp>
+        <p:nvSpPr>
+          <p:cNvPr id="3" name="TextBox 2"/>
+          <p:cNvSpPr txBox="1"/>
+          <p:nvPr/>
+        </p:nvSpPr>
+        <p:spPr>
+          <a:xfrm>
+            <a:off x="324000" y="864000"/>
+            <a:ext cx="11520000" cy="1080000"/>
+          </a:xfrm>
+          <a:prstGeom prst="rect">
+            <a:avLst/>
+          </a:prstGeom>
+          <a:noFill/>
+        </p:spPr>
+        <p:txBody>
+          <a:bodyPr wrap="square">
+            <a:spAutoFit/>
+          </a:bodyPr>
+          <a:lstStyle/>
+          <a:p>
+            <a:pPr>
+              <a:spcAft>
+                <a:spcPts val="600"/>
+              </a:spcAft>
+            </a:pPr>
+            <a:r>
+              <a:rPr sz="1450" b="1">
+                <a:solidFill>
+                  <a:srgbClr val="15181D"/>
+                </a:solidFill>
+                <a:latin typeface="맑은 고딕"/>
+              </a:rPr>
+              <a:t>▪  범위 조정 근거 — v7 실기 수집(30~50ep) · 이어학습 경로가 확정됨:</a:t>
+            </a:r>
+          </a:p>
+          <a:p>
+            <a:pPr lvl="1">
+              <a:spcAft>
+                <a:spcPts val="600"/>
+              </a:spcAft>
+            </a:pPr>
+            <a:r>
+              <a:rPr sz="1300" b="0">
+                <a:solidFill>
+                  <a:srgbClr val="15181D"/>
+                </a:solidFill>
+                <a:latin typeface="맑은 고딕"/>
+              </a:rPr>
+              <a:t>–  새 데이터가 새 카메라 시점으로 수집되므로 'OMX 화면 정밀 재현'의 가치 하락 → 마운트는 기구적으로 튼튼하고 시야 좋은 자리면 충분</a:t>
+            </a:r>
+          </a:p>
+          <a:p>
+            <a:pPr lvl="1">
+              <a:spcAft>
+                <a:spcPts val="600"/>
+              </a:spcAft>
+            </a:pPr>
+            <a:r>
+              <a:rPr sz="1300" b="1">
+                <a:solidFill>
+                  <a:srgbClr val="B45F06"/>
+                </a:solidFill>
+                <a:latin typeface="맑은 고딕"/>
+              </a:rPr>
+              <a:t>–  sim 도메인 갭은 실물 갭의 예측력이 낮음 (렌더와 실물 사진은 서로 다른 방식으로 OMX 영상과 다름) → STEP 5-3 · 5-4 우선순위 하향</a:t>
+            </a:r>
+          </a:p>
+          <a:p>
+            <a:pPr>
+              <a:spcAft>
+                <a:spcPts val="600"/>
+              </a:spcAft>
+            </a:pPr>
+            <a:r>
+              <a:rPr sz="1400" b="1">
+                <a:solidFill>
+                  <a:srgbClr val="15181D"/>
+                </a:solidFill>
+                <a:latin typeface="맑은 고딕"/>
+              </a:rPr>
+              <a:t>▪  원칙: 도착 후에만 할 수 있는 일을 최소화 — 도착 당일부터 v6 궤적 실행 + v7 수집이 돌아가야 함</a:t>
+            </a:r>
+          </a:p>
+        </p:txBody>
+      </p:sp>
+      <p:graphicFrame>
+        <p:nvGraphicFramePr>
+          <p:cNvPr id="4" name="Table 3"/>
+          <p:cNvGraphicFramePr>
+            <a:graphicFrameLocks noGrp="1"/>
+          </p:cNvGraphicFramePr>
+          <p:nvPr/>
+        </p:nvGraphicFramePr>
+        <p:xfrm>
+          <a:off x="324000" y="2160000"/>
+          <a:ext cx="11555998" cy="2700000"/>
+        </p:xfrm>
+        <a:graphic>
+          <a:graphicData uri="http://schemas.openxmlformats.org/drawingml/2006/table">
+            <a:tbl>
+              <a:tblPr firstRow="1" bandRow="1">
+                <a:tableStyleId>{5C22544A-7EE6-4342-B048-85BDC9FD1C3A}</a:tableStyleId>
+              </a:tblPr>
+              <a:tblGrid>
+                <a:gridCol w="1497999"/>
+                <a:gridCol w="7703999"/>
+                <a:gridCol w="2354000"/>
+              </a:tblGrid>
+              <a:tr h="540000">
+                <a:tc>
+                  <a:txBody>
+                    <a:bodyPr/>
+                    <a:lstStyle/>
+                    <a:p>
+                      <a:r>
+                        <a:rPr sz="1200" b="1">
+                          <a:solidFill>
+                            <a:srgbClr val="FFFFFF"/>
+                          </a:solidFill>
+                          <a:latin typeface="맑은 고딕"/>
+                        </a:rPr>
+                        <a:t>주차</a:t>
+                      </a:r>
+                    </a:p>
+                  </a:txBody>
+                  <a:tcPr marL="57600" marR="57600" marT="18000" marB="18000" anchor="ctr">
+                    <a:solidFill>
+                      <a:srgbClr val="2F3D9E"/>
+                    </a:solidFill>
+                  </a:tcPr>
+                </a:tc>
+                <a:tc>
+                  <a:txBody>
+                    <a:bodyPr/>
+                    <a:lstStyle/>
+                    <a:p>
+                      <a:r>
+                        <a:rPr sz="1200" b="1">
+                          <a:solidFill>
+                            <a:srgbClr val="FFFFFF"/>
+                          </a:solidFill>
+                          <a:latin typeface="맑은 고딕"/>
+                        </a:rPr>
+                        <a:t>핵심 작업</a:t>
+                      </a:r>
+                    </a:p>
+                  </a:txBody>
+                  <a:tcPr marL="57600" marR="57600" marT="18000" marB="18000" anchor="ctr">
+                    <a:solidFill>
+                      <a:srgbClr val="2F3D9E"/>
+                    </a:solidFill>
+                  </a:tcPr>
+                </a:tc>
+                <a:tc>
+                  <a:txBody>
+                    <a:bodyPr/>
+                    <a:lstStyle/>
+                    <a:p>
+                      <a:r>
+                        <a:rPr sz="1200" b="1">
+                          <a:solidFill>
+                            <a:srgbClr val="FFFFFF"/>
+                          </a:solidFill>
+                          <a:latin typeface="맑은 고딕"/>
+                        </a:rPr>
+                        <a:t>비고</a:t>
+                      </a:r>
+                    </a:p>
+                  </a:txBody>
+                  <a:tcPr marL="57600" marR="57600" marT="18000" marB="18000" anchor="ctr">
+                    <a:solidFill>
+                      <a:srgbClr val="2F3D9E"/>
+                    </a:solidFill>
+                  </a:tcPr>
+                </a:tc>
+              </a:tr>
+              <a:tr h="540000">
+                <a:tc>
+                  <a:txBody>
+                    <a:bodyPr/>
+                    <a:lstStyle/>
+                    <a:p>
+                      <a:r>
+                        <a:rPr sz="1200" b="0">
+                          <a:solidFill>
+                            <a:srgbClr val="15181D"/>
+                          </a:solidFill>
+                          <a:latin typeface="맑은 고딕"/>
+                        </a:rPr>
+                        <a:t>1주 (8/25~29)</a:t>
+                      </a:r>
+                    </a:p>
+                  </a:txBody>
+                  <a:tcPr marL="57600" marR="57600" marT="18000" marB="18000" anchor="ctr">
+                    <a:solidFill>
+                      <a:srgbClr val="FFFFFF"/>
+                    </a:solidFill>
+                  </a:tcPr>
+                </a:tc>
+                <a:tc>
+                  <a:txBody>
+                    <a:bodyPr/>
+                    <a:lstStyle/>
+                    <a:p>
+                      <a:r>
+                        <a:rPr sz="1200" b="1">
+                          <a:solidFill>
+                            <a:srgbClr val="15181D"/>
+                          </a:solidFill>
+                          <a:latin typeface="맑은 고딕"/>
+                        </a:rPr>
+                        <a:t>LEHR 모델 확정·실측 → TCP 상수 확정 → 재변환(1분)+재학습(~3h) / 카메라 부품 선정·발주</a:t>
+                      </a:r>
+                    </a:p>
+                  </a:txBody>
+                  <a:tcPr marL="57600" marR="57600" marT="18000" marB="18000" anchor="ctr">
+                    <a:solidFill>
+                      <a:srgbClr val="FFFFFF"/>
+                    </a:solidFill>
+                  </a:tcPr>
+                </a:tc>
+                <a:tc>
+                  <a:txBody>
+                    <a:bodyPr/>
+                    <a:lstStyle/>
+                    <a:p>
+                      <a:r>
+                        <a:rPr sz="1200" b="1">
+                          <a:solidFill>
+                            <a:srgbClr val="A9331D"/>
+                          </a:solidFill>
+                          <a:latin typeface="맑은 고딕"/>
+                        </a:rPr>
+                        <a:t>★ 최우선 병목</a:t>
+                      </a:r>
+                    </a:p>
+                  </a:txBody>
+                  <a:tcPr marL="57600" marR="57600" marT="18000" marB="18000" anchor="ctr">
+                    <a:solidFill>
+                      <a:srgbClr val="FFFFFF"/>
+                    </a:solidFill>
+                  </a:tcPr>
+                </a:tc>
+              </a:tr>
+              <a:tr h="540000">
+                <a:tc>
+                  <a:txBody>
+                    <a:bodyPr/>
+                    <a:lstStyle/>
+                    <a:p>
+                      <a:r>
+                        <a:rPr sz="1200" b="0">
+                          <a:solidFill>
+                            <a:srgbClr val="15181D"/>
+                          </a:solidFill>
+                          <a:latin typeface="맑은 고딕"/>
+                        </a:rPr>
+                        <a:t>2주 (9/1~5)</a:t>
+                      </a:r>
+                    </a:p>
+                  </a:txBody>
+                  <a:tcPr marL="57600" marR="57600" marT="18000" marB="18000" anchor="ctr">
+                    <a:solidFill>
+                      <a:srgbClr val="EDEFF3"/>
+                    </a:solidFill>
+                  </a:tcPr>
+                </a:tc>
+                <a:tc>
+                  <a:txBody>
+                    <a:bodyPr/>
+                    <a:lstStyle/>
+                    <a:p>
+                      <a:r>
+                        <a:rPr sz="1200" b="0">
+                          <a:solidFill>
+                            <a:srgbClr val="15181D"/>
+                          </a:solidFill>
+                          <a:latin typeface="맑은 고딕"/>
+                        </a:rPr>
+                        <a:t>손목캠 마운트 + 그리퍼 어태치먼트(일자·연질 팁) 설계·프린팅 / doosan-robot2 가상 모드로 ROS2 환경 선구축</a:t>
+                      </a:r>
+                    </a:p>
+                  </a:txBody>
+                  <a:tcPr marL="57600" marR="57600" marT="18000" marB="18000" anchor="ctr">
+                    <a:solidFill>
+                      <a:srgbClr val="EDEFF3"/>
+                    </a:solidFill>
+                  </a:tcPr>
+                </a:tc>
+                <a:tc>
+                  <a:txBody>
+                    <a:bodyPr/>
+                    <a:lstStyle/>
+                    <a:p>
+                      <a:r>
+                        <a:rPr sz="1200" b="0">
+                          <a:solidFill>
+                            <a:srgbClr val="15181D"/>
+                          </a:solidFill>
+                          <a:latin typeface="맑은 고딕"/>
+                        </a:rPr>
+                        <a:t>카메라 실물 도착 후 치수 확정</a:t>
+                      </a:r>
+                    </a:p>
+                  </a:txBody>
+                  <a:tcPr marL="57600" marR="57600" marT="18000" marB="18000" anchor="ctr">
+                    <a:solidFill>
+                      <a:srgbClr val="EDEFF3"/>
+                    </a:solidFill>
+                  </a:tcPr>
+                </a:tc>
+              </a:tr>
+              <a:tr h="540000">
+                <a:tc>
+                  <a:txBody>
+                    <a:bodyPr/>
+                    <a:lstStyle/>
+                    <a:p>
+                      <a:r>
+                        <a:rPr sz="1200" b="0">
+                          <a:solidFill>
+                            <a:srgbClr val="15181D"/>
+                          </a:solidFill>
+                          <a:latin typeface="맑은 고딕"/>
+                        </a:rPr>
+                        <a:t>3주 (9/8~12)</a:t>
+                      </a:r>
+                    </a:p>
+                  </a:txBody>
+                  <a:tcPr marL="57600" marR="57600" marT="18000" marB="18000" anchor="ctr">
+                    <a:solidFill>
+                      <a:srgbClr val="FFFFFF"/>
+                    </a:solidFill>
+                  </a:tcPr>
+                </a:tc>
+                <a:tc>
+                  <a:txBody>
+                    <a:bodyPr/>
+                    <a:lstStyle/>
+                    <a:p>
+                      <a:r>
+                        <a:rPr sz="1200" b="1">
+                          <a:solidFill>
+                            <a:srgbClr val="15181D"/>
+                          </a:solidFill>
+                          <a:latin typeface="맑은 고딕"/>
+                        </a:rPr>
+                        <a:t>v7 수집 스크립트 (LeRobot 포맷 · 카메라 2대+관절 30Hz 동기) / v6 궤적 실행 스크립트</a:t>
+                      </a:r>
+                    </a:p>
+                  </a:txBody>
+                  <a:tcPr marL="57600" marR="57600" marT="18000" marB="18000" anchor="ctr">
+                    <a:solidFill>
+                      <a:srgbClr val="FFFFFF"/>
+                    </a:solidFill>
+                  </a:tcPr>
+                </a:tc>
+                <a:tc>
+                  <a:txBody>
+                    <a:bodyPr/>
+                    <a:lstStyle/>
+                    <a:p>
+                      <a:r>
+                        <a:rPr sz="1200" b="0">
+                          <a:solidFill>
+                            <a:srgbClr val="15181D"/>
+                          </a:solidFill>
+                          <a:latin typeface="맑은 고딕"/>
+                        </a:rPr>
+                        <a:t>도착 당일 쓸 도구 · 가상 모드로 검증</a:t>
+                      </a:r>
+                    </a:p>
+                  </a:txBody>
+                  <a:tcPr marL="57600" marR="57600" marT="18000" marB="18000" anchor="ctr">
+                    <a:solidFill>
+                      <a:srgbClr val="FFFFFF"/>
+                    </a:solidFill>
+                  </a:tcPr>
+                </a:tc>
+              </a:tr>
+              <a:tr h="540000">
+                <a:tc>
+                  <a:txBody>
+                    <a:bodyPr/>
+                    <a:lstStyle/>
+                    <a:p>
+                      <a:r>
+                        <a:rPr sz="1200" b="0">
+                          <a:solidFill>
+                            <a:srgbClr val="15181D"/>
+                          </a:solidFill>
+                          <a:latin typeface="맑은 고딕"/>
+                        </a:rPr>
+                        <a:t>4주 (9/15~19)</a:t>
+                      </a:r>
+                    </a:p>
+                  </a:txBody>
+                  <a:tcPr marL="57600" marR="57600" marT="18000" marB="18000" anchor="ctr">
+                    <a:solidFill>
+                      <a:srgbClr val="EDEFF3"/>
+                    </a:solidFill>
+                  </a:tcPr>
+                </a:tc>
+                <a:tc>
+                  <a:txBody>
+                    <a:bodyPr/>
+                    <a:lstStyle/>
+                    <a:p>
+                      <a:r>
+                        <a:rPr sz="1200" b="0">
+                          <a:solidFill>
+                            <a:srgbClr val="15181D"/>
+                          </a:solidFill>
+                          <a:latin typeface="맑은 고딕"/>
+                        </a:rPr>
+                        <a:t>통합 리허설 · 도착 당일 절차서 · 버퍼</a:t>
+                      </a:r>
+                    </a:p>
+                  </a:txBody>
+                  <a:tcPr marL="57600" marR="57600" marT="18000" marB="18000" anchor="ctr">
+                    <a:solidFill>
+                      <a:srgbClr val="EDEFF3"/>
+                    </a:solidFill>
+                  </a:tcPr>
+                </a:tc>
+                <a:tc>
+                  <a:txBody>
+                    <a:bodyPr/>
+                    <a:lstStyle/>
+                    <a:p>
+                      <a:r>
+                        <a:rPr sz="1200" b="0">
+                          <a:solidFill>
+                            <a:srgbClr val="15181D"/>
+                          </a:solidFill>
+                          <a:latin typeface="맑은 고딕"/>
+                        </a:rPr>
+                        <a:t>Isaac 을 실물 대역으로 사용</a:t>
+                      </a:r>
+                    </a:p>
+                  </a:txBody>
+                  <a:tcPr marL="57600" marR="57600" marT="18000" marB="18000" anchor="ctr">
+                    <a:solidFill>
+                      <a:srgbClr val="EDEFF3"/>
+                    </a:solidFill>
+                  </a:tcPr>
+                </a:tc>
+              </a:tr>
+            </a:tbl>
+          </a:graphicData>
+        </a:graphic>
+      </p:graphicFrame>
+      <p:sp>
+        <p:nvSpPr>
+          <p:cNvPr id="5" name="TextBox 4"/>
+          <p:cNvSpPr txBox="1"/>
+          <p:nvPr/>
+        </p:nvSpPr>
+        <p:spPr>
+          <a:xfrm>
+            <a:off x="324000" y="4968000"/>
+            <a:ext cx="5616000" cy="1584000"/>
+          </a:xfrm>
+          <a:prstGeom prst="rect">
+            <a:avLst/>
+          </a:prstGeom>
+          <a:noFill/>
+        </p:spPr>
+        <p:txBody>
+          <a:bodyPr wrap="square">
+            <a:spAutoFit/>
+          </a:bodyPr>
+          <a:lstStyle/>
+          <a:p>
+            <a:pPr>
+              <a:spcAft>
+                <a:spcPts val="600"/>
+              </a:spcAft>
+            </a:pPr>
+            <a:r>
+              <a:rPr sz="1350" b="1">
+                <a:solidFill>
+                  <a:srgbClr val="A9331D"/>
+                </a:solidFill>
+                <a:latin typeface="맑은 고딕"/>
+              </a:rPr>
+              <a:t>▪  LEHR 확정이 최우선인 이유 — 3가지를 동시에 막고 있음:</a:t>
+            </a:r>
+          </a:p>
+          <a:p>
+            <a:pPr lvl="1">
+              <a:spcAft>
+                <a:spcPts val="600"/>
+              </a:spcAft>
+            </a:pPr>
+            <a:r>
+              <a:rPr sz="1250" b="0">
+                <a:solidFill>
+                  <a:srgbClr val="15181D"/>
+                </a:solidFill>
+                <a:latin typeface="맑은 고딕"/>
+              </a:rPr>
+              <a:t>–  TCP 0.12m 잠정값 확정 불가 (→ 데이터셋 미확정)</a:t>
+            </a:r>
+          </a:p>
+          <a:p>
+            <a:pPr lvl="1">
+              <a:spcAft>
+                <a:spcPts val="600"/>
+              </a:spcAft>
+            </a:pPr>
+            <a:r>
+              <a:rPr sz="1250" b="0">
+                <a:solidFill>
+                  <a:srgbClr val="15181D"/>
+                </a:solidFill>
+                <a:latin typeface="맑은 고딕"/>
+              </a:rPr>
+              <a:t>–  그리퍼 어태치먼트 설계 불가</a:t>
+            </a:r>
+          </a:p>
+          <a:p>
+            <a:pPr lvl="1">
+              <a:spcAft>
+                <a:spcPts val="600"/>
+              </a:spcAft>
+            </a:pPr>
+            <a:r>
+              <a:rPr sz="1250" b="0">
+                <a:solidFill>
+                  <a:srgbClr val="15181D"/>
+                </a:solidFill>
+                <a:latin typeface="맑은 고딕"/>
+              </a:rPr>
+              <a:t>–  손목캠 마운트 설계 불가 (카메라가 그리퍼를 피해야 함)</a:t>
+            </a:r>
+          </a:p>
+        </p:txBody>
+      </p:sp>
+      <p:sp>
+        <p:nvSpPr>
+          <p:cNvPr id="6" name="TextBox 5"/>
+          <p:cNvSpPr txBox="1"/>
+          <p:nvPr/>
+        </p:nvSpPr>
+        <p:spPr>
+          <a:xfrm>
+            <a:off x="6192000" y="4968000"/>
+            <a:ext cx="5688000" cy="1584000"/>
+          </a:xfrm>
+          <a:prstGeom prst="rect">
+            <a:avLst/>
+          </a:prstGeom>
+          <a:noFill/>
+        </p:spPr>
+        <p:txBody>
+          <a:bodyPr wrap="square">
+            <a:spAutoFit/>
+          </a:bodyPr>
+          <a:lstStyle/>
+          <a:p>
+            <a:pPr>
+              <a:spcAft>
+                <a:spcPts val="600"/>
+              </a:spcAft>
+            </a:pPr>
+            <a:r>
+              <a:rPr sz="1350" b="1">
+                <a:solidFill>
+                  <a:srgbClr val="15181D"/>
+                </a:solidFill>
+                <a:latin typeface="맑은 고딕"/>
+              </a:rPr>
+              <a:t>▪  카메라 선정 기준:</a:t>
+            </a:r>
+          </a:p>
+          <a:p>
+            <a:pPr lvl="1">
+              <a:spcAft>
+                <a:spcPts val="600"/>
+              </a:spcAft>
+            </a:pPr>
+            <a:r>
+              <a:rPr sz="1250" b="0">
+                <a:solidFill>
+                  <a:srgbClr val="15181D"/>
+                </a:solidFill>
+                <a:latin typeface="맑은 고딕"/>
+              </a:rPr>
+              <a:t>–  FOV 60~70° 대역 · 소형(그리퍼 옆 장착) · USB UVC(기존 수집 코드 재사용)</a:t>
+            </a:r>
+          </a:p>
+          <a:p>
+            <a:pPr lvl="1">
+              <a:spcAft>
+                <a:spcPts val="600"/>
+              </a:spcAft>
+            </a:pPr>
+            <a:r>
+              <a:rPr sz="1250" b="1">
+                <a:solidFill>
+                  <a:srgbClr val="1F6B4A"/>
+                </a:solidFill>
+                <a:latin typeface="맑은 고딕"/>
+              </a:rPr>
+              <a:t>–  정면캠은 OMX 리그의 것을 그대로 옮겨 쓰는 것이 최선 — 같은 카메라면 화질·색감·왜곡이 일치해 도메인 갭이 줄어듦</a:t>
+            </a:r>
+          </a:p>
+        </p:txBody>
+      </p:sp>
+      <p:sp>
+        <p:nvSpPr>
+          <p:cNvPr id="7" name="TextBox 6"/>
+          <p:cNvSpPr txBox="1"/>
+          <p:nvPr/>
+        </p:nvSpPr>
+        <p:spPr>
+          <a:xfrm>
+            <a:off x="324000" y="6598800"/>
+            <a:ext cx="11544119" cy="216000"/>
+          </a:xfrm>
+          <a:prstGeom prst="rect">
+            <a:avLst/>
+          </a:prstGeom>
+          <a:noFill/>
+        </p:spPr>
+        <p:txBody>
+          <a:bodyPr wrap="square">
+            <a:spAutoFit/>
+          </a:bodyPr>
+          <a:lstStyle/>
+          <a:p>
+            <a:r>
+              <a:rPr sz="1000" b="0">
+                <a:solidFill>
+                  <a:srgbClr val="626B78"/>
+                </a:solidFill>
+                <a:latin typeface="맑은 고딕"/>
+              </a:rPr>
+              <a:t>M1013 전이 · STEP 5 카메라 정합 · 2026-08-24</a:t>
+            </a:r>
+          </a:p>
+        </p:txBody>
+      </p:sp>
+    </p:spTree>
+  </p:cSld>
+  <p:clrMapOvr>
+    <a:masterClrMapping/>
+  </p:clrMapOvr>
+</p:sld>
+</file>
+
+<file path=ppt/slides/slide17.xml><?xml version="1.0" encoding="utf-8"?>
+<p:sld xmlns:a="http://schemas.openxmlformats.org/drawingml/2006/main" xmlns:p="http://schemas.openxmlformats.org/presentationml/2006/main" xmlns:r="http://schemas.openxmlformats.org/officeDocument/2006/relationships">
+  <p:cSld>
+    <p:spTree>
+      <p:nvGrpSpPr>
+        <p:cNvPr id="1" name=""/>
+        <p:cNvGrpSpPr/>
+        <p:nvPr/>
+      </p:nvGrpSpPr>
+      <p:grpSpPr/>
+      <p:sp>
+        <p:nvSpPr>
+          <p:cNvPr id="2" name="Rectangle 1"/>
+          <p:cNvSpPr/>
+          <p:nvPr/>
+        </p:nvSpPr>
+        <p:spPr>
+          <a:xfrm>
+            <a:off x="0" y="0"/>
+            <a:ext cx="12192119" cy="720000"/>
+          </a:xfrm>
+          <a:prstGeom prst="rect">
+            <a:avLst/>
+          </a:prstGeom>
+          <a:solidFill>
+            <a:srgbClr val="2F3D9E"/>
+          </a:solidFill>
+          <a:ln>
+            <a:noFill/>
+          </a:ln>
+        </p:spPr>
+        <p:style>
+          <a:lnRef idx="1">
+            <a:schemeClr val="accent1"/>
+          </a:lnRef>
+          <a:fillRef idx="3">
+            <a:schemeClr val="accent1"/>
+          </a:fillRef>
+          <a:effectRef idx="2">
+            <a:schemeClr val="accent1"/>
+          </a:effectRef>
+          <a:fontRef idx="minor">
+            <a:schemeClr val="lt1"/>
+          </a:fontRef>
+        </p:style>
+        <p:txBody>
+          <a:bodyPr rtlCol="0" anchor="ctr" lIns="324000" tIns="93600"/>
+          <a:lstStyle/>
+          <a:p>
+            <a:pPr algn="ctr"/>
+            <a:r>
+              <a:rPr sz="1500" b="1">
+                <a:solidFill>
+                  <a:srgbClr val="B9C2F0"/>
+                </a:solidFill>
+                <a:latin typeface="맑은 고딕"/>
+              </a:rPr>
+              <a:t>12 참조  </a:t>
             </a:r>
             <a:r>
               <a:rPr sz="2100" b="1">
@@ -6491,13 +8642,13 @@
               </a:spcAft>
             </a:pPr>
             <a:r>
-              <a:rPr sz="1350" b="0">
+              <a:rPr sz="1350" b="1">
                 <a:solidFill>
                   <a:srgbClr val="15181D"/>
                 </a:solidFill>
                 <a:latin typeface="맑은 고딕"/>
               </a:rPr>
-              <a:t>–  다음 세션은 closed_loop_m1013.py 작성부터 (관측 규약 확인 → 추론 브릿지 결정 → 8ep A/B)</a:t>
+              <a:t>–  다음은 closed-loop 이 아니라 실물 도착(9/20) 준비 — LEHR 확정 · 카메라 발주 · v7 수집 스크립트 순</a:t>
             </a:r>
           </a:p>
         </p:txBody>
@@ -7425,7 +9576,7 @@
                 </a:solidFill>
                 <a:latin typeface="맑은 고딕"/>
               </a:rPr>
-              <a:t>로봇 도착 후</a:t>
+              <a:t>9/20 도착 예정</a:t>
             </a:r>
           </a:p>
         </p:txBody>
@@ -7789,7 +9940,7 @@
             <a:avLst/>
           </a:prstGeom>
           <a:solidFill>
-            <a:srgbClr val="B45F06"/>
+            <a:srgbClr val="626B78"/>
           </a:solidFill>
           <a:ln w="9525">
             <a:solidFill>
@@ -7877,11 +10028,11 @@
             <a:r>
               <a:rPr sz="1150" b="1">
                 <a:solidFill>
-                  <a:srgbClr val="B45F06"/>
-                </a:solidFill>
-                <a:latin typeface="맑은 고딕"/>
-              </a:rPr>
-              <a:t>다음 시작점 ▶</a:t>
+                  <a:srgbClr val="626B78"/>
+                </a:solidFill>
+                <a:latin typeface="맑은 고딕"/>
+              </a:rPr>
+              <a:t>우선순위 하향 (13장)</a:t>
             </a:r>
           </a:p>
         </p:txBody>
@@ -8036,7 +10187,7 @@
                 </a:solidFill>
                 <a:latin typeface="맑은 고딕"/>
               </a:rPr>
-              <a:t>5-3 결과에 따라</a:t>
+              <a:t>보류</a:t>
             </a:r>
           </a:p>
         </p:txBody>
@@ -11311,11 +13462,11 @@
                       <a:r>
                         <a:rPr sz="1200" b="0">
                           <a:solidFill>
-                            <a:srgbClr val="15181D"/>
+                            <a:srgbClr val="A9331D"/>
                           </a:solidFill>
                           <a:latin typeface="맑은 고딕"/>
                         </a:rPr>
-                        <a:t>원본 씬에 캘리브레이션 타깃이 없고, 로봇 자체가 다름(OMX→M1013) — 정확한 해가 존재하지 않는 문제</a:t>
+                        <a:t>당시 '타깃 없음'으로 기각 — 그러나 오판. 큐브 파지 위치가 곧 타깃이었음 (13장에서 정정)</a:t>
                       </a:r>
                     </a:p>
                   </a:txBody>

</xml_diff>